<commit_message>
docs: update course decks and notes, add handout; ignore working/
Co-Authored-By: Claude Sonnet 5 <noreply@anthropic.com>
</commit_message>
<xml_diff>
--- a/docs/TCA-Opening.pptx
+++ b/docs/TCA-Opening.pptx
@@ -4,11 +4,14 @@
   <p:sldMasterIdLst>
     <p:sldMasterId id="2147483648" r:id="rId1"/>
   </p:sldMasterIdLst>
+  <p:notesMasterIdLst>
+    <p:notesMasterId r:id="rId13"/>
+  </p:notesMasterIdLst>
   <p:sldIdLst>
     <p:sldId id="256" r:id="rId2"/>
     <p:sldId id="267" r:id="rId3"/>
-    <p:sldId id="260" r:id="rId4"/>
-    <p:sldId id="268" r:id="rId5"/>
+    <p:sldId id="268" r:id="rId4"/>
+    <p:sldId id="260" r:id="rId5"/>
     <p:sldId id="257" r:id="rId6"/>
     <p:sldId id="258" r:id="rId7"/>
     <p:sldId id="259" r:id="rId8"/>
@@ -1458,7 +1461,7 @@
   <dgm:whole/>
   <dgm:extLst>
     <a:ext uri="http://schemas.microsoft.com/office/drawing/2008/diagram">
-      <dsp:dataModelExt xmlns:dsp="http://schemas.microsoft.com/office/drawing/2008/diagram" relId="rId7" minVer="http://schemas.openxmlformats.org/drawingml/2006/diagram"/>
+      <dsp:dataModelExt xmlns:dsp="http://schemas.microsoft.com/office/drawing/2008/diagram" relId="rId8" minVer="http://schemas.openxmlformats.org/drawingml/2006/diagram"/>
     </a:ext>
   </dgm:extLst>
 </dgm:dataModel>
@@ -3489,6 +3492,545 @@
 </dgm:styleDef>
 </file>
 
+<file path=ppt/notesMasters/notesMaster1.xml><?xml version="1.0" encoding="utf-8"?>
+<p:notesMaster xmlns:a="http://schemas.openxmlformats.org/drawingml/2006/main" xmlns:r="http://schemas.openxmlformats.org/officeDocument/2006/relationships" xmlns:p="http://schemas.openxmlformats.org/presentationml/2006/main">
+  <p:cSld>
+    <p:bg>
+      <p:bgRef idx="1001">
+        <a:schemeClr val="bg1"/>
+      </p:bgRef>
+    </p:bg>
+    <p:spTree>
+      <p:nvGrpSpPr>
+        <p:cNvPr id="1" name=""/>
+        <p:cNvGrpSpPr/>
+        <p:nvPr/>
+      </p:nvGrpSpPr>
+      <p:grpSpPr>
+        <a:xfrm>
+          <a:off x="0" y="0"/>
+          <a:ext cx="0" cy="0"/>
+          <a:chOff x="0" y="0"/>
+          <a:chExt cx="0" cy="0"/>
+        </a:xfrm>
+      </p:grpSpPr>
+      <p:sp>
+        <p:nvSpPr>
+          <p:cNvPr id="2" name="Header Placeholder 1"/>
+          <p:cNvSpPr>
+            <a:spLocks noGrp="1"/>
+          </p:cNvSpPr>
+          <p:nvPr>
+            <p:ph type="hdr" sz="quarter"/>
+          </p:nvPr>
+        </p:nvSpPr>
+        <p:spPr>
+          <a:xfrm>
+            <a:off x="0" y="0"/>
+            <a:ext cx="2971800" cy="458788"/>
+          </a:xfrm>
+          <a:prstGeom prst="rect">
+            <a:avLst/>
+          </a:prstGeom>
+        </p:spPr>
+        <p:txBody>
+          <a:bodyPr vert="horz" lIns="91440" tIns="45720" rIns="91440" bIns="45720" rtlCol="0"/>
+          <a:lstStyle>
+            <a:lvl1pPr algn="l">
+              <a:defRPr sz="1200"/>
+            </a:lvl1pPr>
+          </a:lstStyle>
+          <a:p>
+            <a:endParaRPr lang="en-AU"/>
+          </a:p>
+        </p:txBody>
+      </p:sp>
+      <p:sp>
+        <p:nvSpPr>
+          <p:cNvPr id="3" name="Date Placeholder 2"/>
+          <p:cNvSpPr>
+            <a:spLocks noGrp="1"/>
+          </p:cNvSpPr>
+          <p:nvPr>
+            <p:ph type="dt" idx="1"/>
+          </p:nvPr>
+        </p:nvSpPr>
+        <p:spPr>
+          <a:xfrm>
+            <a:off x="3884613" y="0"/>
+            <a:ext cx="2971800" cy="458788"/>
+          </a:xfrm>
+          <a:prstGeom prst="rect">
+            <a:avLst/>
+          </a:prstGeom>
+        </p:spPr>
+        <p:txBody>
+          <a:bodyPr vert="horz" lIns="91440" tIns="45720" rIns="91440" bIns="45720" rtlCol="0"/>
+          <a:lstStyle>
+            <a:lvl1pPr algn="r">
+              <a:defRPr sz="1200"/>
+            </a:lvl1pPr>
+          </a:lstStyle>
+          <a:p>
+            <a:fld id="{1759264F-4DF6-2E40-B9FF-FB19C3894662}" type="datetimeFigureOut">
+              <a:rPr lang="en-AU" smtClean="0"/>
+              <a:t>29/7/2026</a:t>
+            </a:fld>
+            <a:endParaRPr lang="en-AU"/>
+          </a:p>
+        </p:txBody>
+      </p:sp>
+      <p:sp>
+        <p:nvSpPr>
+          <p:cNvPr id="4" name="Slide Image Placeholder 3"/>
+          <p:cNvSpPr>
+            <a:spLocks noGrp="1" noRot="1" noChangeAspect="1"/>
+          </p:cNvSpPr>
+          <p:nvPr>
+            <p:ph type="sldImg" idx="2"/>
+          </p:nvPr>
+        </p:nvSpPr>
+        <p:spPr>
+          <a:xfrm>
+            <a:off x="685800" y="1143000"/>
+            <a:ext cx="5486400" cy="3086100"/>
+          </a:xfrm>
+          <a:prstGeom prst="rect">
+            <a:avLst/>
+          </a:prstGeom>
+          <a:noFill/>
+          <a:ln w="12700">
+            <a:solidFill>
+              <a:prstClr val="black"/>
+            </a:solidFill>
+          </a:ln>
+        </p:spPr>
+        <p:txBody>
+          <a:bodyPr vert="horz" lIns="91440" tIns="45720" rIns="91440" bIns="45720" rtlCol="0" anchor="ctr"/>
+          <a:lstStyle/>
+          <a:p>
+            <a:endParaRPr lang="en-AU"/>
+          </a:p>
+        </p:txBody>
+      </p:sp>
+      <p:sp>
+        <p:nvSpPr>
+          <p:cNvPr id="5" name="Notes Placeholder 4"/>
+          <p:cNvSpPr>
+            <a:spLocks noGrp="1"/>
+          </p:cNvSpPr>
+          <p:nvPr>
+            <p:ph type="body" sz="quarter" idx="3"/>
+          </p:nvPr>
+        </p:nvSpPr>
+        <p:spPr>
+          <a:xfrm>
+            <a:off x="685800" y="4400550"/>
+            <a:ext cx="5486400" cy="3600450"/>
+          </a:xfrm>
+          <a:prstGeom prst="rect">
+            <a:avLst/>
+          </a:prstGeom>
+        </p:spPr>
+        <p:txBody>
+          <a:bodyPr vert="horz" lIns="91440" tIns="45720" rIns="91440" bIns="45720" rtlCol="0"/>
+          <a:lstStyle/>
+          <a:p>
+            <a:pPr lvl="0"/>
+            <a:r>
+              <a:rPr lang="en-GB"/>
+              <a:t>Click to edit Master text styles</a:t>
+            </a:r>
+          </a:p>
+          <a:p>
+            <a:pPr lvl="1"/>
+            <a:r>
+              <a:rPr lang="en-GB"/>
+              <a:t>Second level</a:t>
+            </a:r>
+          </a:p>
+          <a:p>
+            <a:pPr lvl="2"/>
+            <a:r>
+              <a:rPr lang="en-GB"/>
+              <a:t>Third level</a:t>
+            </a:r>
+          </a:p>
+          <a:p>
+            <a:pPr lvl="3"/>
+            <a:r>
+              <a:rPr lang="en-GB"/>
+              <a:t>Fourth level</a:t>
+            </a:r>
+          </a:p>
+          <a:p>
+            <a:pPr lvl="4"/>
+            <a:r>
+              <a:rPr lang="en-GB"/>
+              <a:t>Fifth level</a:t>
+            </a:r>
+            <a:endParaRPr lang="en-AU"/>
+          </a:p>
+        </p:txBody>
+      </p:sp>
+      <p:sp>
+        <p:nvSpPr>
+          <p:cNvPr id="6" name="Footer Placeholder 5"/>
+          <p:cNvSpPr>
+            <a:spLocks noGrp="1"/>
+          </p:cNvSpPr>
+          <p:nvPr>
+            <p:ph type="ftr" sz="quarter" idx="4"/>
+          </p:nvPr>
+        </p:nvSpPr>
+        <p:spPr>
+          <a:xfrm>
+            <a:off x="0" y="8685213"/>
+            <a:ext cx="2971800" cy="458787"/>
+          </a:xfrm>
+          <a:prstGeom prst="rect">
+            <a:avLst/>
+          </a:prstGeom>
+        </p:spPr>
+        <p:txBody>
+          <a:bodyPr vert="horz" lIns="91440" tIns="45720" rIns="91440" bIns="45720" rtlCol="0" anchor="b"/>
+          <a:lstStyle>
+            <a:lvl1pPr algn="l">
+              <a:defRPr sz="1200"/>
+            </a:lvl1pPr>
+          </a:lstStyle>
+          <a:p>
+            <a:endParaRPr lang="en-AU"/>
+          </a:p>
+        </p:txBody>
+      </p:sp>
+      <p:sp>
+        <p:nvSpPr>
+          <p:cNvPr id="7" name="Slide Number Placeholder 6"/>
+          <p:cNvSpPr>
+            <a:spLocks noGrp="1"/>
+          </p:cNvSpPr>
+          <p:nvPr>
+            <p:ph type="sldNum" sz="quarter" idx="5"/>
+          </p:nvPr>
+        </p:nvSpPr>
+        <p:spPr>
+          <a:xfrm>
+            <a:off x="3884613" y="8685213"/>
+            <a:ext cx="2971800" cy="458787"/>
+          </a:xfrm>
+          <a:prstGeom prst="rect">
+            <a:avLst/>
+          </a:prstGeom>
+        </p:spPr>
+        <p:txBody>
+          <a:bodyPr vert="horz" lIns="91440" tIns="45720" rIns="91440" bIns="45720" rtlCol="0" anchor="b"/>
+          <a:lstStyle>
+            <a:lvl1pPr algn="r">
+              <a:defRPr sz="1200"/>
+            </a:lvl1pPr>
+          </a:lstStyle>
+          <a:p>
+            <a:fld id="{C9486565-23E4-7A40-B92C-B76925F2B224}" type="slidenum">
+              <a:rPr lang="en-AU" smtClean="0"/>
+              <a:t>‹#›</a:t>
+            </a:fld>
+            <a:endParaRPr lang="en-AU"/>
+          </a:p>
+        </p:txBody>
+      </p:sp>
+    </p:spTree>
+    <p:extLst>
+      <p:ext uri="{BB962C8B-B14F-4D97-AF65-F5344CB8AC3E}">
+        <p14:creationId xmlns:p14="http://schemas.microsoft.com/office/powerpoint/2010/main" val="2991928134"/>
+      </p:ext>
+    </p:extLst>
+  </p:cSld>
+  <p:clrMap bg1="lt1" tx1="dk1" bg2="lt2" tx2="dk2" accent1="accent1" accent2="accent2" accent3="accent3" accent4="accent4" accent5="accent5" accent6="accent6" hlink="hlink" folHlink="folHlink"/>
+  <p:notesStyle>
+    <a:lvl1pPr marL="0" algn="l" defTabSz="914400" rtl="0" eaLnBrk="1" latinLnBrk="0" hangingPunct="1">
+      <a:defRPr sz="1200" kern="1200">
+        <a:solidFill>
+          <a:schemeClr val="tx1"/>
+        </a:solidFill>
+        <a:latin typeface="+mn-lt"/>
+        <a:ea typeface="+mn-ea"/>
+        <a:cs typeface="+mn-cs"/>
+      </a:defRPr>
+    </a:lvl1pPr>
+    <a:lvl2pPr marL="457200" algn="l" defTabSz="914400" rtl="0" eaLnBrk="1" latinLnBrk="0" hangingPunct="1">
+      <a:defRPr sz="1200" kern="1200">
+        <a:solidFill>
+          <a:schemeClr val="tx1"/>
+        </a:solidFill>
+        <a:latin typeface="+mn-lt"/>
+        <a:ea typeface="+mn-ea"/>
+        <a:cs typeface="+mn-cs"/>
+      </a:defRPr>
+    </a:lvl2pPr>
+    <a:lvl3pPr marL="914400" algn="l" defTabSz="914400" rtl="0" eaLnBrk="1" latinLnBrk="0" hangingPunct="1">
+      <a:defRPr sz="1200" kern="1200">
+        <a:solidFill>
+          <a:schemeClr val="tx1"/>
+        </a:solidFill>
+        <a:latin typeface="+mn-lt"/>
+        <a:ea typeface="+mn-ea"/>
+        <a:cs typeface="+mn-cs"/>
+      </a:defRPr>
+    </a:lvl3pPr>
+    <a:lvl4pPr marL="1371600" algn="l" defTabSz="914400" rtl="0" eaLnBrk="1" latinLnBrk="0" hangingPunct="1">
+      <a:defRPr sz="1200" kern="1200">
+        <a:solidFill>
+          <a:schemeClr val="tx1"/>
+        </a:solidFill>
+        <a:latin typeface="+mn-lt"/>
+        <a:ea typeface="+mn-ea"/>
+        <a:cs typeface="+mn-cs"/>
+      </a:defRPr>
+    </a:lvl4pPr>
+    <a:lvl5pPr marL="1828800" algn="l" defTabSz="914400" rtl="0" eaLnBrk="1" latinLnBrk="0" hangingPunct="1">
+      <a:defRPr sz="1200" kern="1200">
+        <a:solidFill>
+          <a:schemeClr val="tx1"/>
+        </a:solidFill>
+        <a:latin typeface="+mn-lt"/>
+        <a:ea typeface="+mn-ea"/>
+        <a:cs typeface="+mn-cs"/>
+      </a:defRPr>
+    </a:lvl5pPr>
+    <a:lvl6pPr marL="2286000" algn="l" defTabSz="914400" rtl="0" eaLnBrk="1" latinLnBrk="0" hangingPunct="1">
+      <a:defRPr sz="1200" kern="1200">
+        <a:solidFill>
+          <a:schemeClr val="tx1"/>
+        </a:solidFill>
+        <a:latin typeface="+mn-lt"/>
+        <a:ea typeface="+mn-ea"/>
+        <a:cs typeface="+mn-cs"/>
+      </a:defRPr>
+    </a:lvl6pPr>
+    <a:lvl7pPr marL="2743200" algn="l" defTabSz="914400" rtl="0" eaLnBrk="1" latinLnBrk="0" hangingPunct="1">
+      <a:defRPr sz="1200" kern="1200">
+        <a:solidFill>
+          <a:schemeClr val="tx1"/>
+        </a:solidFill>
+        <a:latin typeface="+mn-lt"/>
+        <a:ea typeface="+mn-ea"/>
+        <a:cs typeface="+mn-cs"/>
+      </a:defRPr>
+    </a:lvl7pPr>
+    <a:lvl8pPr marL="3200400" algn="l" defTabSz="914400" rtl="0" eaLnBrk="1" latinLnBrk="0" hangingPunct="1">
+      <a:defRPr sz="1200" kern="1200">
+        <a:solidFill>
+          <a:schemeClr val="tx1"/>
+        </a:solidFill>
+        <a:latin typeface="+mn-lt"/>
+        <a:ea typeface="+mn-ea"/>
+        <a:cs typeface="+mn-cs"/>
+      </a:defRPr>
+    </a:lvl8pPr>
+    <a:lvl9pPr marL="3657600" algn="l" defTabSz="914400" rtl="0" eaLnBrk="1" latinLnBrk="0" hangingPunct="1">
+      <a:defRPr sz="1200" kern="1200">
+        <a:solidFill>
+          <a:schemeClr val="tx1"/>
+        </a:solidFill>
+        <a:latin typeface="+mn-lt"/>
+        <a:ea typeface="+mn-ea"/>
+        <a:cs typeface="+mn-cs"/>
+      </a:defRPr>
+    </a:lvl9pPr>
+  </p:notesStyle>
+</p:notesMaster>
+</file>
+
+<file path=ppt/notesSlides/notesSlide1.xml><?xml version="1.0" encoding="utf-8"?>
+<p:notes xmlns:a="http://schemas.openxmlformats.org/drawingml/2006/main" xmlns:r="http://schemas.openxmlformats.org/officeDocument/2006/relationships" xmlns:p="http://schemas.openxmlformats.org/presentationml/2006/main">
+  <p:cSld>
+    <p:spTree>
+      <p:nvGrpSpPr>
+        <p:cNvPr id="1" name=""/>
+        <p:cNvGrpSpPr/>
+        <p:nvPr/>
+      </p:nvGrpSpPr>
+      <p:grpSpPr>
+        <a:xfrm>
+          <a:off x="0" y="0"/>
+          <a:ext cx="0" cy="0"/>
+          <a:chOff x="0" y="0"/>
+          <a:chExt cx="0" cy="0"/>
+        </a:xfrm>
+      </p:grpSpPr>
+      <p:sp>
+        <p:nvSpPr>
+          <p:cNvPr id="2" name="Slide Image Placeholder 1"/>
+          <p:cNvSpPr>
+            <a:spLocks noGrp="1" noRot="1" noChangeAspect="1"/>
+          </p:cNvSpPr>
+          <p:nvPr>
+            <p:ph type="sldImg"/>
+          </p:nvPr>
+        </p:nvSpPr>
+        <p:spPr/>
+      </p:sp>
+      <p:sp>
+        <p:nvSpPr>
+          <p:cNvPr id="3" name="Notes Placeholder 2"/>
+          <p:cNvSpPr>
+            <a:spLocks noGrp="1"/>
+          </p:cNvSpPr>
+          <p:nvPr>
+            <p:ph type="body" idx="1"/>
+          </p:nvPr>
+        </p:nvSpPr>
+        <p:spPr/>
+        <p:txBody>
+          <a:bodyPr/>
+          <a:lstStyle/>
+          <a:p>
+            <a:r>
+              <a:rPr lang="en-AU" dirty="0"/>
+              <a:t>Introductions of teachers, plus habit question</a:t>
+            </a:r>
+          </a:p>
+          <a:p>
+            <a:r>
+              <a:rPr lang="en-AU" dirty="0"/>
+              <a:t>Then around the grounds</a:t>
+            </a:r>
+          </a:p>
+        </p:txBody>
+      </p:sp>
+      <p:sp>
+        <p:nvSpPr>
+          <p:cNvPr id="4" name="Slide Number Placeholder 3"/>
+          <p:cNvSpPr>
+            <a:spLocks noGrp="1"/>
+          </p:cNvSpPr>
+          <p:nvPr>
+            <p:ph type="sldNum" sz="quarter" idx="5"/>
+          </p:nvPr>
+        </p:nvSpPr>
+        <p:spPr/>
+        <p:txBody>
+          <a:bodyPr/>
+          <a:lstStyle/>
+          <a:p>
+            <a:fld id="{C9486565-23E4-7A40-B92C-B76925F2B224}" type="slidenum">
+              <a:rPr lang="en-AU" smtClean="0"/>
+              <a:t>3</a:t>
+            </a:fld>
+            <a:endParaRPr lang="en-AU"/>
+          </a:p>
+        </p:txBody>
+      </p:sp>
+    </p:spTree>
+    <p:extLst>
+      <p:ext uri="{BB962C8B-B14F-4D97-AF65-F5344CB8AC3E}">
+        <p14:creationId xmlns:p14="http://schemas.microsoft.com/office/powerpoint/2010/main" val="1717718290"/>
+      </p:ext>
+    </p:extLst>
+  </p:cSld>
+  <p:clrMapOvr>
+    <a:masterClrMapping/>
+  </p:clrMapOvr>
+</p:notes>
+</file>
+
+<file path=ppt/notesSlides/notesSlide2.xml><?xml version="1.0" encoding="utf-8"?>
+<p:notes xmlns:a="http://schemas.openxmlformats.org/drawingml/2006/main" xmlns:r="http://schemas.openxmlformats.org/officeDocument/2006/relationships" xmlns:p="http://schemas.openxmlformats.org/presentationml/2006/main">
+  <p:cSld>
+    <p:spTree>
+      <p:nvGrpSpPr>
+        <p:cNvPr id="1" name=""/>
+        <p:cNvGrpSpPr/>
+        <p:nvPr/>
+      </p:nvGrpSpPr>
+      <p:grpSpPr>
+        <a:xfrm>
+          <a:off x="0" y="0"/>
+          <a:ext cx="0" cy="0"/>
+          <a:chOff x="0" y="0"/>
+          <a:chExt cx="0" cy="0"/>
+        </a:xfrm>
+      </p:grpSpPr>
+      <p:sp>
+        <p:nvSpPr>
+          <p:cNvPr id="2" name="Slide Image Placeholder 1"/>
+          <p:cNvSpPr>
+            <a:spLocks noGrp="1" noRot="1" noChangeAspect="1"/>
+          </p:cNvSpPr>
+          <p:nvPr>
+            <p:ph type="sldImg"/>
+          </p:nvPr>
+        </p:nvSpPr>
+        <p:spPr/>
+      </p:sp>
+      <p:sp>
+        <p:nvSpPr>
+          <p:cNvPr id="3" name="Notes Placeholder 2"/>
+          <p:cNvSpPr>
+            <a:spLocks noGrp="1"/>
+          </p:cNvSpPr>
+          <p:nvPr>
+            <p:ph type="body" idx="1"/>
+          </p:nvPr>
+        </p:nvSpPr>
+        <p:spPr/>
+        <p:txBody>
+          <a:bodyPr/>
+          <a:lstStyle/>
+          <a:p>
+            <a:r>
+              <a:rPr lang="en-AU" sz="1200" kern="1200" dirty="0">
+                <a:solidFill>
+                  <a:schemeClr val="tx1"/>
+                </a:solidFill>
+                <a:effectLst/>
+                <a:latin typeface="+mn-lt"/>
+                <a:ea typeface="+mn-ea"/>
+                <a:cs typeface="+mn-cs"/>
+              </a:rPr>
+              <a:t>A habit tracker, themed for people coming back to a full life: family routines, fitness, hobbies. Add habits, tick them off each day, watch a streak grow, break the chain and it resets. </a:t>
+            </a:r>
+            <a:endParaRPr lang="en-AU" dirty="0"/>
+          </a:p>
+        </p:txBody>
+      </p:sp>
+      <p:sp>
+        <p:nvSpPr>
+          <p:cNvPr id="4" name="Slide Number Placeholder 3"/>
+          <p:cNvSpPr>
+            <a:spLocks noGrp="1"/>
+          </p:cNvSpPr>
+          <p:nvPr>
+            <p:ph type="sldNum" sz="quarter" idx="5"/>
+          </p:nvPr>
+        </p:nvSpPr>
+        <p:spPr/>
+        <p:txBody>
+          <a:bodyPr/>
+          <a:lstStyle/>
+          <a:p>
+            <a:fld id="{C9486565-23E4-7A40-B92C-B76925F2B224}" type="slidenum">
+              <a:rPr lang="en-AU" smtClean="0"/>
+              <a:t>7</a:t>
+            </a:fld>
+            <a:endParaRPr lang="en-AU"/>
+          </a:p>
+        </p:txBody>
+      </p:sp>
+    </p:spTree>
+    <p:extLst>
+      <p:ext uri="{BB962C8B-B14F-4D97-AF65-F5344CB8AC3E}">
+        <p14:creationId xmlns:p14="http://schemas.microsoft.com/office/powerpoint/2010/main" val="1891360270"/>
+      </p:ext>
+    </p:extLst>
+  </p:cSld>
+  <p:clrMapOvr>
+    <a:masterClrMapping/>
+  </p:clrMapOvr>
+</p:notes>
+</file>
+
 <file path=ppt/slideLayouts/slideLayout1.xml><?xml version="1.0" encoding="utf-8"?>
 <p:sldLayout xmlns:a="http://schemas.openxmlformats.org/drawingml/2006/main" xmlns:r="http://schemas.openxmlformats.org/officeDocument/2006/relationships" xmlns:p="http://schemas.openxmlformats.org/presentationml/2006/main" type="title" preserve="1">
   <p:cSld name="Title Slide">
@@ -3668,7 +4210,7 @@
           <a:p>
             <a:fld id="{5BCAD085-E8A6-8845-BD4E-CB4CCA059FC4}" type="datetimeFigureOut">
               <a:rPr lang="en-US" smtClean="0"/>
-              <a:t>7/27/26</a:t>
+              <a:t>7/29/26</a:t>
             </a:fld>
             <a:endParaRPr lang="en-US"/>
           </a:p>
@@ -3836,7 +4378,7 @@
           <a:p>
             <a:fld id="{5BCAD085-E8A6-8845-BD4E-CB4CCA059FC4}" type="datetimeFigureOut">
               <a:rPr lang="en-US" smtClean="0"/>
-              <a:t>7/27/26</a:t>
+              <a:t>7/29/26</a:t>
             </a:fld>
             <a:endParaRPr lang="en-US"/>
           </a:p>
@@ -4014,7 +4556,7 @@
           <a:p>
             <a:fld id="{5BCAD085-E8A6-8845-BD4E-CB4CCA059FC4}" type="datetimeFigureOut">
               <a:rPr lang="en-US" smtClean="0"/>
-              <a:t>7/27/26</a:t>
+              <a:t>7/29/26</a:t>
             </a:fld>
             <a:endParaRPr lang="en-US"/>
           </a:p>
@@ -4182,7 +4724,7 @@
           <a:p>
             <a:fld id="{5BCAD085-E8A6-8845-BD4E-CB4CCA059FC4}" type="datetimeFigureOut">
               <a:rPr lang="en-US" smtClean="0"/>
-              <a:t>7/27/26</a:t>
+              <a:t>7/29/26</a:t>
             </a:fld>
             <a:endParaRPr lang="en-US"/>
           </a:p>
@@ -4427,7 +4969,7 @@
           <a:p>
             <a:fld id="{5BCAD085-E8A6-8845-BD4E-CB4CCA059FC4}" type="datetimeFigureOut">
               <a:rPr lang="en-US" smtClean="0"/>
-              <a:t>7/27/26</a:t>
+              <a:t>7/29/26</a:t>
             </a:fld>
             <a:endParaRPr lang="en-US"/>
           </a:p>
@@ -4712,7 +5254,7 @@
           <a:p>
             <a:fld id="{5BCAD085-E8A6-8845-BD4E-CB4CCA059FC4}" type="datetimeFigureOut">
               <a:rPr lang="en-US" smtClean="0"/>
-              <a:t>7/27/26</a:t>
+              <a:t>7/29/26</a:t>
             </a:fld>
             <a:endParaRPr lang="en-US"/>
           </a:p>
@@ -5131,7 +5673,7 @@
           <a:p>
             <a:fld id="{5BCAD085-E8A6-8845-BD4E-CB4CCA059FC4}" type="datetimeFigureOut">
               <a:rPr lang="en-US" smtClean="0"/>
-              <a:t>7/27/26</a:t>
+              <a:t>7/29/26</a:t>
             </a:fld>
             <a:endParaRPr lang="en-US"/>
           </a:p>
@@ -5248,7 +5790,7 @@
           <a:p>
             <a:fld id="{5BCAD085-E8A6-8845-BD4E-CB4CCA059FC4}" type="datetimeFigureOut">
               <a:rPr lang="en-US" smtClean="0"/>
-              <a:t>7/27/26</a:t>
+              <a:t>7/29/26</a:t>
             </a:fld>
             <a:endParaRPr lang="en-US"/>
           </a:p>
@@ -5343,7 +5885,7 @@
           <a:p>
             <a:fld id="{5BCAD085-E8A6-8845-BD4E-CB4CCA059FC4}" type="datetimeFigureOut">
               <a:rPr lang="en-US" smtClean="0"/>
-              <a:t>7/27/26</a:t>
+              <a:t>7/29/26</a:t>
             </a:fld>
             <a:endParaRPr lang="en-US"/>
           </a:p>
@@ -5618,7 +6160,7 @@
           <a:p>
             <a:fld id="{5BCAD085-E8A6-8845-BD4E-CB4CCA059FC4}" type="datetimeFigureOut">
               <a:rPr lang="en-US" smtClean="0"/>
-              <a:t>7/27/26</a:t>
+              <a:t>7/29/26</a:t>
             </a:fld>
             <a:endParaRPr lang="en-US"/>
           </a:p>
@@ -5870,7 +6412,7 @@
           <a:p>
             <a:fld id="{5BCAD085-E8A6-8845-BD4E-CB4CCA059FC4}" type="datetimeFigureOut">
               <a:rPr lang="en-US" smtClean="0"/>
-              <a:t>7/27/26</a:t>
+              <a:t>7/29/26</a:t>
             </a:fld>
             <a:endParaRPr lang="en-US"/>
           </a:p>
@@ -6081,7 +6623,7 @@
           <a:p>
             <a:fld id="{5BCAD085-E8A6-8845-BD4E-CB4CCA059FC4}" type="datetimeFigureOut">
               <a:rPr lang="en-US" smtClean="0"/>
-              <a:t>7/27/26</a:t>
+              <a:t>7/29/26</a:t>
             </a:fld>
             <a:endParaRPr lang="en-US"/>
           </a:p>
@@ -7788,6 +8330,36 @@
       </p:grpSpPr>
       <p:pic>
         <p:nvPicPr>
+          <p:cNvPr id="4" name="Picture 3" descr="Official Artwork | Illawarra Aboriginal Corporation">
+            <a:extLst>
+              <a:ext uri="{FF2B5EF4-FFF2-40B4-BE49-F238E27FC236}">
+                <a16:creationId xmlns:a16="http://schemas.microsoft.com/office/drawing/2014/main" id="{7406F579-B9A2-7C4B-D32D-ACF7DE84C3C9}"/>
+              </a:ext>
+            </a:extLst>
+          </p:cNvPr>
+          <p:cNvPicPr>
+            <a:picLocks noChangeAspect="1"/>
+          </p:cNvPicPr>
+          <p:nvPr/>
+        </p:nvPicPr>
+        <p:blipFill>
+          <a:blip r:embed="rId2"/>
+          <a:stretch>
+            <a:fillRect/>
+          </a:stretch>
+        </p:blipFill>
+        <p:spPr>
+          <a:xfrm>
+            <a:off x="0" y="0"/>
+            <a:ext cx="9144000" cy="4610680"/>
+          </a:xfrm>
+          <a:prstGeom prst="rect">
+            <a:avLst/>
+          </a:prstGeom>
+        </p:spPr>
+      </p:pic>
+      <p:pic>
+        <p:nvPicPr>
           <p:cNvPr id="2" name="Picture 1" descr="image1.jpeg">
             <a:extLst>
               <a:ext uri="{FF2B5EF4-FFF2-40B4-BE49-F238E27FC236}">
@@ -7801,7 +8373,7 @@
           <p:nvPr/>
         </p:nvPicPr>
         <p:blipFill>
-          <a:blip r:embed="rId2"/>
+          <a:blip r:embed="rId3"/>
           <a:stretch>
             <a:fillRect/>
           </a:stretch>
@@ -7830,7 +8402,7 @@
         </p:nvSpPr>
         <p:spPr>
           <a:xfrm>
-            <a:off x="457200" y="292608"/>
+            <a:off x="578744" y="1987439"/>
             <a:ext cx="8229600" cy="338554"/>
           </a:xfrm>
           <a:prstGeom prst="rect">
@@ -7877,8 +8449,8 @@
         </p:nvSpPr>
         <p:spPr>
           <a:xfrm>
-            <a:off x="457200" y="1463040"/>
-            <a:ext cx="8229600" cy="2512612"/>
+            <a:off x="548640" y="2325993"/>
+            <a:ext cx="8229600" cy="2144406"/>
           </a:xfrm>
           <a:prstGeom prst="rect">
             <a:avLst/>
@@ -7930,7 +8502,7 @@
         </p:nvSpPr>
         <p:spPr>
           <a:xfrm>
-            <a:off x="822960" y="1823652"/>
+            <a:off x="785330" y="2531477"/>
             <a:ext cx="7498079" cy="1791388"/>
           </a:xfrm>
           <a:prstGeom prst="rect">
@@ -7981,1001 +8553,6 @@
 </file>
 
 <file path=ppt/slides/slide3.xml><?xml version="1.0" encoding="utf-8"?>
-<p:sld xmlns:a="http://schemas.openxmlformats.org/drawingml/2006/main" xmlns:r="http://schemas.openxmlformats.org/officeDocument/2006/relationships" xmlns:p="http://schemas.openxmlformats.org/presentationml/2006/main">
-  <p:cSld>
-    <p:bg>
-      <p:bgPr>
-        <a:solidFill>
-          <a:srgbClr val="F5F3FF"/>
-        </a:solidFill>
-        <a:effectLst/>
-      </p:bgPr>
-    </p:bg>
-    <p:spTree>
-      <p:nvGrpSpPr>
-        <p:cNvPr id="1" name=""/>
-        <p:cNvGrpSpPr/>
-        <p:nvPr/>
-      </p:nvGrpSpPr>
-      <p:grpSpPr>
-        <a:xfrm>
-          <a:off x="0" y="0"/>
-          <a:ext cx="0" cy="0"/>
-          <a:chOff x="0" y="0"/>
-          <a:chExt cx="0" cy="0"/>
-        </a:xfrm>
-      </p:grpSpPr>
-      <p:sp>
-        <p:nvSpPr>
-          <p:cNvPr id="2" name="TextBox 1"/>
-          <p:cNvSpPr txBox="1"/>
-          <p:nvPr/>
-        </p:nvSpPr>
-        <p:spPr>
-          <a:xfrm>
-            <a:off x="457200" y="292608"/>
-            <a:ext cx="8229600" cy="566928"/>
-          </a:xfrm>
-          <a:prstGeom prst="rect">
-            <a:avLst/>
-          </a:prstGeom>
-          <a:noFill/>
-        </p:spPr>
-        <p:txBody>
-          <a:bodyPr wrap="square" lIns="0" tIns="0" rIns="0" bIns="0" anchor="t">
-            <a:spAutoFit/>
-          </a:bodyPr>
-          <a:lstStyle/>
-          <a:p>
-            <a:pPr algn="l"/>
-            <a:r>
-              <a:rPr sz="2200" b="1">
-                <a:solidFill>
-                  <a:srgbClr val="2D1155"/>
-                </a:solidFill>
-                <a:latin typeface="Arial Black"/>
-              </a:rPr>
-              <a:t>RUN OF DAY</a:t>
-            </a:r>
-          </a:p>
-        </p:txBody>
-      </p:sp>
-      <p:sp>
-        <p:nvSpPr>
-          <p:cNvPr id="3" name="TextBox 2"/>
-          <p:cNvSpPr txBox="1"/>
-          <p:nvPr/>
-        </p:nvSpPr>
-        <p:spPr>
-          <a:xfrm>
-            <a:off x="475488" y="896112"/>
-            <a:ext cx="8229600" cy="329184"/>
-          </a:xfrm>
-          <a:prstGeom prst="rect">
-            <a:avLst/>
-          </a:prstGeom>
-          <a:noFill/>
-        </p:spPr>
-        <p:txBody>
-          <a:bodyPr wrap="square" lIns="0" tIns="0" rIns="0" bIns="0" anchor="t">
-            <a:spAutoFit/>
-          </a:bodyPr>
-          <a:lstStyle/>
-          <a:p>
-            <a:pPr algn="l"/>
-            <a:r>
-              <a:rPr sz="1300" b="0">
-                <a:solidFill>
-                  <a:srgbClr val="6E6389"/>
-                </a:solidFill>
-                <a:latin typeface="Calibri"/>
-              </a:rPr>
-              <a:t>Segment lengths are what matter. Times assume a 09:30 start.</a:t>
-            </a:r>
-          </a:p>
-        </p:txBody>
-      </p:sp>
-      <p:pic>
-        <p:nvPicPr>
-          <p:cNvPr id="4" name="Picture 3" descr="image1.jpeg"/>
-          <p:cNvPicPr>
-            <a:picLocks noChangeAspect="1"/>
-          </p:cNvPicPr>
-          <p:nvPr/>
-        </p:nvPicPr>
-        <p:blipFill>
-          <a:blip r:embed="rId2"/>
-          <a:stretch>
-            <a:fillRect/>
-          </a:stretch>
-        </p:blipFill>
-        <p:spPr>
-          <a:xfrm>
-            <a:off x="8366760" y="4526280"/>
-            <a:ext cx="411480" cy="411480"/>
-          </a:xfrm>
-          <a:prstGeom prst="rect">
-            <a:avLst/>
-          </a:prstGeom>
-        </p:spPr>
-      </p:pic>
-      <p:sp>
-        <p:nvSpPr>
-          <p:cNvPr id="5" name="TextBox 4"/>
-          <p:cNvSpPr txBox="1"/>
-          <p:nvPr/>
-        </p:nvSpPr>
-        <p:spPr>
-          <a:xfrm>
-            <a:off x="566928" y="1371600"/>
-            <a:ext cx="914400" cy="274320"/>
-          </a:xfrm>
-          <a:prstGeom prst="rect">
-            <a:avLst/>
-          </a:prstGeom>
-          <a:noFill/>
-        </p:spPr>
-        <p:txBody>
-          <a:bodyPr wrap="square" lIns="0" tIns="0" rIns="0" bIns="0" anchor="t">
-            <a:spAutoFit/>
-          </a:bodyPr>
-          <a:lstStyle/>
-          <a:p>
-            <a:pPr algn="l"/>
-            <a:r>
-              <a:rPr sz="900" b="1">
-                <a:solidFill>
-                  <a:srgbClr val="6E6389"/>
-                </a:solidFill>
-                <a:latin typeface="Calibri"/>
-              </a:rPr>
-              <a:t>TIME</a:t>
-            </a:r>
-          </a:p>
-        </p:txBody>
-      </p:sp>
-      <p:sp>
-        <p:nvSpPr>
-          <p:cNvPr id="6" name="TextBox 5"/>
-          <p:cNvSpPr txBox="1"/>
-          <p:nvPr/>
-        </p:nvSpPr>
-        <p:spPr>
-          <a:xfrm>
-            <a:off x="1737360" y="1371600"/>
-            <a:ext cx="5486400" cy="274320"/>
-          </a:xfrm>
-          <a:prstGeom prst="rect">
-            <a:avLst/>
-          </a:prstGeom>
-          <a:noFill/>
-        </p:spPr>
-        <p:txBody>
-          <a:bodyPr wrap="square" lIns="0" tIns="0" rIns="0" bIns="0" anchor="t">
-            <a:spAutoFit/>
-          </a:bodyPr>
-          <a:lstStyle/>
-          <a:p>
-            <a:pPr algn="l"/>
-            <a:r>
-              <a:rPr sz="900" b="1">
-                <a:solidFill>
-                  <a:srgbClr val="6E6389"/>
-                </a:solidFill>
-                <a:latin typeface="Calibri"/>
-              </a:rPr>
-              <a:t>SEGMENT</a:t>
-            </a:r>
-          </a:p>
-        </p:txBody>
-      </p:sp>
-      <p:sp>
-        <p:nvSpPr>
-          <p:cNvPr id="8" name="TextBox 7"/>
-          <p:cNvSpPr txBox="1"/>
-          <p:nvPr/>
-        </p:nvSpPr>
-        <p:spPr>
-          <a:xfrm>
-            <a:off x="566928" y="1682496"/>
-            <a:ext cx="1005840" cy="338328"/>
-          </a:xfrm>
-          <a:prstGeom prst="rect">
-            <a:avLst/>
-          </a:prstGeom>
-          <a:noFill/>
-        </p:spPr>
-        <p:txBody>
-          <a:bodyPr wrap="square" lIns="0" tIns="0" rIns="0" bIns="0" anchor="ctr">
-            <a:spAutoFit/>
-          </a:bodyPr>
-          <a:lstStyle/>
-          <a:p>
-            <a:pPr algn="l"/>
-            <a:r>
-              <a:rPr sz="1200" b="1">
-                <a:solidFill>
-                  <a:srgbClr val="7C3AED"/>
-                </a:solidFill>
-                <a:latin typeface="Calibri"/>
-              </a:rPr>
-              <a:t>09:30</a:t>
-            </a:r>
-          </a:p>
-        </p:txBody>
-      </p:sp>
-      <p:sp>
-        <p:nvSpPr>
-          <p:cNvPr id="9" name="TextBox 8"/>
-          <p:cNvSpPr txBox="1"/>
-          <p:nvPr/>
-        </p:nvSpPr>
-        <p:spPr>
-          <a:xfrm>
-            <a:off x="1737360" y="1682496"/>
-            <a:ext cx="5486400" cy="338328"/>
-          </a:xfrm>
-          <a:prstGeom prst="rect">
-            <a:avLst/>
-          </a:prstGeom>
-          <a:noFill/>
-        </p:spPr>
-        <p:txBody>
-          <a:bodyPr wrap="square" lIns="0" tIns="0" rIns="0" bIns="0" anchor="ctr">
-            <a:spAutoFit/>
-          </a:bodyPr>
-          <a:lstStyle/>
-          <a:p>
-            <a:pPr algn="l"/>
-            <a:r>
-              <a:rPr sz="1200" b="0">
-                <a:solidFill>
-                  <a:srgbClr val="6E6389"/>
-                </a:solidFill>
-                <a:latin typeface="Calibri"/>
-              </a:rPr>
-              <a:t>Welcome, introduction, setup check — the day’s shape</a:t>
-            </a:r>
-          </a:p>
-        </p:txBody>
-      </p:sp>
-      <p:sp>
-        <p:nvSpPr>
-          <p:cNvPr id="11" name="TextBox 10"/>
-          <p:cNvSpPr txBox="1"/>
-          <p:nvPr/>
-        </p:nvSpPr>
-        <p:spPr>
-          <a:xfrm>
-            <a:off x="566928" y="2020824"/>
-            <a:ext cx="1005840" cy="338328"/>
-          </a:xfrm>
-          <a:prstGeom prst="rect">
-            <a:avLst/>
-          </a:prstGeom>
-          <a:noFill/>
-        </p:spPr>
-        <p:txBody>
-          <a:bodyPr wrap="square" lIns="0" tIns="0" rIns="0" bIns="0" anchor="ctr">
-            <a:spAutoFit/>
-          </a:bodyPr>
-          <a:lstStyle/>
-          <a:p>
-            <a:pPr algn="l"/>
-            <a:r>
-              <a:rPr sz="1200" b="1">
-                <a:solidFill>
-                  <a:srgbClr val="7C3AED"/>
-                </a:solidFill>
-                <a:latin typeface="Calibri"/>
-              </a:rPr>
-              <a:t>09:45</a:t>
-            </a:r>
-          </a:p>
-        </p:txBody>
-      </p:sp>
-      <p:sp>
-        <p:nvSpPr>
-          <p:cNvPr id="12" name="TextBox 11"/>
-          <p:cNvSpPr txBox="1"/>
-          <p:nvPr/>
-        </p:nvSpPr>
-        <p:spPr>
-          <a:xfrm>
-            <a:off x="1737360" y="2020824"/>
-            <a:ext cx="5486400" cy="338328"/>
-          </a:xfrm>
-          <a:prstGeom prst="rect">
-            <a:avLst/>
-          </a:prstGeom>
-          <a:noFill/>
-        </p:spPr>
-        <p:txBody>
-          <a:bodyPr wrap="square" lIns="0" tIns="0" rIns="0" bIns="0" anchor="ctr">
-            <a:spAutoFit/>
-          </a:bodyPr>
-          <a:lstStyle/>
-          <a:p>
-            <a:pPr algn="l"/>
-            <a:r>
-              <a:rPr sz="1200" b="0" dirty="0">
-                <a:solidFill>
-                  <a:srgbClr val="6E6389"/>
-                </a:solidFill>
-                <a:latin typeface="Calibri"/>
-              </a:rPr>
-              <a:t>How the engineer’s life has changed</a:t>
-            </a:r>
-          </a:p>
-        </p:txBody>
-      </p:sp>
-      <p:sp>
-        <p:nvSpPr>
-          <p:cNvPr id="14" name="Rectangle 13"/>
-          <p:cNvSpPr/>
-          <p:nvPr/>
-        </p:nvSpPr>
-        <p:spPr>
-          <a:xfrm>
-            <a:off x="457200" y="2359152"/>
-            <a:ext cx="7680960" cy="338328"/>
-          </a:xfrm>
-          <a:prstGeom prst="rect">
-            <a:avLst/>
-          </a:prstGeom>
-          <a:solidFill>
-            <a:srgbClr val="FFFFFF"/>
-          </a:solidFill>
-          <a:ln w="12700">
-            <a:solidFill>
-              <a:srgbClr val="DDD6FE"/>
-            </a:solidFill>
-          </a:ln>
-          <a:effectLst/>
-        </p:spPr>
-        <p:style>
-          <a:lnRef idx="1">
-            <a:schemeClr val="accent1"/>
-          </a:lnRef>
-          <a:fillRef idx="3">
-            <a:schemeClr val="accent1"/>
-          </a:fillRef>
-          <a:effectRef idx="2">
-            <a:schemeClr val="accent1"/>
-          </a:effectRef>
-          <a:fontRef idx="minor">
-            <a:schemeClr val="lt1"/>
-          </a:fontRef>
-        </p:style>
-        <p:txBody>
-          <a:bodyPr rtlCol="0" anchor="ctr"/>
-          <a:lstStyle/>
-          <a:p>
-            <a:pPr algn="ctr"/>
-            <a:endParaRPr/>
-          </a:p>
-        </p:txBody>
-      </p:sp>
-      <p:sp>
-        <p:nvSpPr>
-          <p:cNvPr id="15" name="TextBox 14"/>
-          <p:cNvSpPr txBox="1"/>
-          <p:nvPr/>
-        </p:nvSpPr>
-        <p:spPr>
-          <a:xfrm>
-            <a:off x="566928" y="2359152"/>
-            <a:ext cx="1005840" cy="338328"/>
-          </a:xfrm>
-          <a:prstGeom prst="rect">
-            <a:avLst/>
-          </a:prstGeom>
-          <a:noFill/>
-        </p:spPr>
-        <p:txBody>
-          <a:bodyPr wrap="square" lIns="0" tIns="0" rIns="0" bIns="0" anchor="ctr">
-            <a:spAutoFit/>
-          </a:bodyPr>
-          <a:lstStyle/>
-          <a:p>
-            <a:pPr algn="l"/>
-            <a:r>
-              <a:rPr sz="1200" b="1">
-                <a:solidFill>
-                  <a:srgbClr val="7C3AED"/>
-                </a:solidFill>
-                <a:latin typeface="Calibri"/>
-              </a:rPr>
-              <a:t>10:00</a:t>
-            </a:r>
-          </a:p>
-        </p:txBody>
-      </p:sp>
-      <p:sp>
-        <p:nvSpPr>
-          <p:cNvPr id="16" name="TextBox 15"/>
-          <p:cNvSpPr txBox="1"/>
-          <p:nvPr/>
-        </p:nvSpPr>
-        <p:spPr>
-          <a:xfrm>
-            <a:off x="1737360" y="2359152"/>
-            <a:ext cx="5486400" cy="338328"/>
-          </a:xfrm>
-          <a:prstGeom prst="rect">
-            <a:avLst/>
-          </a:prstGeom>
-          <a:noFill/>
-        </p:spPr>
-        <p:txBody>
-          <a:bodyPr wrap="square" lIns="0" tIns="0" rIns="0" bIns="0" anchor="ctr">
-            <a:spAutoFit/>
-          </a:bodyPr>
-          <a:lstStyle/>
-          <a:p>
-            <a:pPr algn="l"/>
-            <a:r>
-              <a:rPr sz="1250" b="1">
-                <a:solidFill>
-                  <a:srgbClr val="2D1155"/>
-                </a:solidFill>
-                <a:latin typeface="Arial Black"/>
-              </a:rPr>
-              <a:t>Section 1 · Vibe Coding</a:t>
-            </a:r>
-          </a:p>
-        </p:txBody>
-      </p:sp>
-      <p:sp>
-        <p:nvSpPr>
-          <p:cNvPr id="18" name="TextBox 17"/>
-          <p:cNvSpPr txBox="1"/>
-          <p:nvPr/>
-        </p:nvSpPr>
-        <p:spPr>
-          <a:xfrm>
-            <a:off x="566928" y="2697480"/>
-            <a:ext cx="1005840" cy="338328"/>
-          </a:xfrm>
-          <a:prstGeom prst="rect">
-            <a:avLst/>
-          </a:prstGeom>
-          <a:noFill/>
-        </p:spPr>
-        <p:txBody>
-          <a:bodyPr wrap="square" lIns="0" tIns="0" rIns="0" bIns="0" anchor="ctr">
-            <a:spAutoFit/>
-          </a:bodyPr>
-          <a:lstStyle/>
-          <a:p>
-            <a:pPr algn="l"/>
-            <a:r>
-              <a:rPr sz="1200" b="1">
-                <a:solidFill>
-                  <a:srgbClr val="7C3AED"/>
-                </a:solidFill>
-                <a:latin typeface="Calibri"/>
-              </a:rPr>
-              <a:t>11:30</a:t>
-            </a:r>
-          </a:p>
-        </p:txBody>
-      </p:sp>
-      <p:sp>
-        <p:nvSpPr>
-          <p:cNvPr id="19" name="TextBox 18"/>
-          <p:cNvSpPr txBox="1"/>
-          <p:nvPr/>
-        </p:nvSpPr>
-        <p:spPr>
-          <a:xfrm>
-            <a:off x="1737360" y="2697480"/>
-            <a:ext cx="5486400" cy="338328"/>
-          </a:xfrm>
-          <a:prstGeom prst="rect">
-            <a:avLst/>
-          </a:prstGeom>
-          <a:noFill/>
-        </p:spPr>
-        <p:txBody>
-          <a:bodyPr wrap="square" lIns="0" tIns="0" rIns="0" bIns="0" anchor="ctr">
-            <a:spAutoFit/>
-          </a:bodyPr>
-          <a:lstStyle/>
-          <a:p>
-            <a:pPr algn="l"/>
-            <a:r>
-              <a:rPr sz="1200" b="0">
-                <a:solidFill>
-                  <a:srgbClr val="6E6389"/>
-                </a:solidFill>
-                <a:latin typeface="Calibri"/>
-              </a:rPr>
-              <a:t>Break</a:t>
-            </a:r>
-          </a:p>
-        </p:txBody>
-      </p:sp>
-      <p:sp>
-        <p:nvSpPr>
-          <p:cNvPr id="21" name="Rectangle 20"/>
-          <p:cNvSpPr/>
-          <p:nvPr/>
-        </p:nvSpPr>
-        <p:spPr>
-          <a:xfrm>
-            <a:off x="457200" y="3035808"/>
-            <a:ext cx="7680960" cy="338328"/>
-          </a:xfrm>
-          <a:prstGeom prst="rect">
-            <a:avLst/>
-          </a:prstGeom>
-          <a:solidFill>
-            <a:srgbClr val="FFFFFF"/>
-          </a:solidFill>
-          <a:ln w="12700">
-            <a:solidFill>
-              <a:srgbClr val="DDD6FE"/>
-            </a:solidFill>
-          </a:ln>
-          <a:effectLst/>
-        </p:spPr>
-        <p:style>
-          <a:lnRef idx="1">
-            <a:schemeClr val="accent1"/>
-          </a:lnRef>
-          <a:fillRef idx="3">
-            <a:schemeClr val="accent1"/>
-          </a:fillRef>
-          <a:effectRef idx="2">
-            <a:schemeClr val="accent1"/>
-          </a:effectRef>
-          <a:fontRef idx="minor">
-            <a:schemeClr val="lt1"/>
-          </a:fontRef>
-        </p:style>
-        <p:txBody>
-          <a:bodyPr rtlCol="0" anchor="ctr"/>
-          <a:lstStyle/>
-          <a:p>
-            <a:pPr algn="ctr"/>
-            <a:endParaRPr/>
-          </a:p>
-        </p:txBody>
-      </p:sp>
-      <p:sp>
-        <p:nvSpPr>
-          <p:cNvPr id="22" name="TextBox 21"/>
-          <p:cNvSpPr txBox="1"/>
-          <p:nvPr/>
-        </p:nvSpPr>
-        <p:spPr>
-          <a:xfrm>
-            <a:off x="566928" y="3035808"/>
-            <a:ext cx="1005840" cy="338328"/>
-          </a:xfrm>
-          <a:prstGeom prst="rect">
-            <a:avLst/>
-          </a:prstGeom>
-          <a:noFill/>
-        </p:spPr>
-        <p:txBody>
-          <a:bodyPr wrap="square" lIns="0" tIns="0" rIns="0" bIns="0" anchor="ctr">
-            <a:spAutoFit/>
-          </a:bodyPr>
-          <a:lstStyle/>
-          <a:p>
-            <a:pPr algn="l"/>
-            <a:r>
-              <a:rPr sz="1200" b="1">
-                <a:solidFill>
-                  <a:srgbClr val="7C3AED"/>
-                </a:solidFill>
-                <a:latin typeface="Calibri"/>
-              </a:rPr>
-              <a:t>11:45</a:t>
-            </a:r>
-          </a:p>
-        </p:txBody>
-      </p:sp>
-      <p:sp>
-        <p:nvSpPr>
-          <p:cNvPr id="23" name="TextBox 22"/>
-          <p:cNvSpPr txBox="1"/>
-          <p:nvPr/>
-        </p:nvSpPr>
-        <p:spPr>
-          <a:xfrm>
-            <a:off x="1737360" y="3035808"/>
-            <a:ext cx="5486400" cy="338328"/>
-          </a:xfrm>
-          <a:prstGeom prst="rect">
-            <a:avLst/>
-          </a:prstGeom>
-          <a:noFill/>
-        </p:spPr>
-        <p:txBody>
-          <a:bodyPr wrap="square" lIns="0" tIns="0" rIns="0" bIns="0" anchor="ctr">
-            <a:spAutoFit/>
-          </a:bodyPr>
-          <a:lstStyle/>
-          <a:p>
-            <a:pPr algn="l"/>
-            <a:r>
-              <a:rPr sz="1250" b="1">
-                <a:solidFill>
-                  <a:srgbClr val="2D1155"/>
-                </a:solidFill>
-                <a:latin typeface="Arial Black"/>
-              </a:rPr>
-              <a:t>Section 2 · Vibe Engineering</a:t>
-            </a:r>
-          </a:p>
-        </p:txBody>
-      </p:sp>
-      <p:sp>
-        <p:nvSpPr>
-          <p:cNvPr id="25" name="TextBox 24"/>
-          <p:cNvSpPr txBox="1"/>
-          <p:nvPr/>
-        </p:nvSpPr>
-        <p:spPr>
-          <a:xfrm>
-            <a:off x="566928" y="3374136"/>
-            <a:ext cx="1005840" cy="338328"/>
-          </a:xfrm>
-          <a:prstGeom prst="rect">
-            <a:avLst/>
-          </a:prstGeom>
-          <a:noFill/>
-        </p:spPr>
-        <p:txBody>
-          <a:bodyPr wrap="square" lIns="0" tIns="0" rIns="0" bIns="0" anchor="ctr">
-            <a:spAutoFit/>
-          </a:bodyPr>
-          <a:lstStyle/>
-          <a:p>
-            <a:pPr algn="l"/>
-            <a:r>
-              <a:rPr sz="1200" b="1">
-                <a:solidFill>
-                  <a:srgbClr val="7C3AED"/>
-                </a:solidFill>
-                <a:latin typeface="Calibri"/>
-              </a:rPr>
-              <a:t>13:15</a:t>
-            </a:r>
-          </a:p>
-        </p:txBody>
-      </p:sp>
-      <p:sp>
-        <p:nvSpPr>
-          <p:cNvPr id="26" name="TextBox 25"/>
-          <p:cNvSpPr txBox="1"/>
-          <p:nvPr/>
-        </p:nvSpPr>
-        <p:spPr>
-          <a:xfrm>
-            <a:off x="1737360" y="3374136"/>
-            <a:ext cx="5486400" cy="338328"/>
-          </a:xfrm>
-          <a:prstGeom prst="rect">
-            <a:avLst/>
-          </a:prstGeom>
-          <a:noFill/>
-        </p:spPr>
-        <p:txBody>
-          <a:bodyPr wrap="square" lIns="0" tIns="0" rIns="0" bIns="0" anchor="ctr">
-            <a:spAutoFit/>
-          </a:bodyPr>
-          <a:lstStyle/>
-          <a:p>
-            <a:pPr algn="l"/>
-            <a:r>
-              <a:rPr sz="1200" b="0">
-                <a:solidFill>
-                  <a:srgbClr val="6E6389"/>
-                </a:solidFill>
-                <a:latin typeface="Calibri"/>
-              </a:rPr>
-              <a:t>Lunch</a:t>
-            </a:r>
-          </a:p>
-        </p:txBody>
-      </p:sp>
-      <p:sp>
-        <p:nvSpPr>
-          <p:cNvPr id="28" name="Rectangle 27"/>
-          <p:cNvSpPr/>
-          <p:nvPr/>
-        </p:nvSpPr>
-        <p:spPr>
-          <a:xfrm>
-            <a:off x="457200" y="3712464"/>
-            <a:ext cx="7680960" cy="338328"/>
-          </a:xfrm>
-          <a:prstGeom prst="rect">
-            <a:avLst/>
-          </a:prstGeom>
-          <a:solidFill>
-            <a:srgbClr val="FFFFFF"/>
-          </a:solidFill>
-          <a:ln w="12700">
-            <a:solidFill>
-              <a:srgbClr val="DDD6FE"/>
-            </a:solidFill>
-          </a:ln>
-          <a:effectLst/>
-        </p:spPr>
-        <p:style>
-          <a:lnRef idx="1">
-            <a:schemeClr val="accent1"/>
-          </a:lnRef>
-          <a:fillRef idx="3">
-            <a:schemeClr val="accent1"/>
-          </a:fillRef>
-          <a:effectRef idx="2">
-            <a:schemeClr val="accent1"/>
-          </a:effectRef>
-          <a:fontRef idx="minor">
-            <a:schemeClr val="lt1"/>
-          </a:fontRef>
-        </p:style>
-        <p:txBody>
-          <a:bodyPr rtlCol="0" anchor="ctr"/>
-          <a:lstStyle/>
-          <a:p>
-            <a:pPr algn="ctr"/>
-            <a:endParaRPr/>
-          </a:p>
-        </p:txBody>
-      </p:sp>
-      <p:sp>
-        <p:nvSpPr>
-          <p:cNvPr id="29" name="TextBox 28"/>
-          <p:cNvSpPr txBox="1"/>
-          <p:nvPr/>
-        </p:nvSpPr>
-        <p:spPr>
-          <a:xfrm>
-            <a:off x="566928" y="3712464"/>
-            <a:ext cx="1005840" cy="338328"/>
-          </a:xfrm>
-          <a:prstGeom prst="rect">
-            <a:avLst/>
-          </a:prstGeom>
-          <a:noFill/>
-        </p:spPr>
-        <p:txBody>
-          <a:bodyPr wrap="square" lIns="0" tIns="0" rIns="0" bIns="0" anchor="ctr">
-            <a:spAutoFit/>
-          </a:bodyPr>
-          <a:lstStyle/>
-          <a:p>
-            <a:pPr algn="l"/>
-            <a:r>
-              <a:rPr sz="1200" b="1">
-                <a:solidFill>
-                  <a:srgbClr val="7C3AED"/>
-                </a:solidFill>
-                <a:latin typeface="Calibri"/>
-              </a:rPr>
-              <a:t>14:00</a:t>
-            </a:r>
-          </a:p>
-        </p:txBody>
-      </p:sp>
-      <p:sp>
-        <p:nvSpPr>
-          <p:cNvPr id="30" name="TextBox 29"/>
-          <p:cNvSpPr txBox="1"/>
-          <p:nvPr/>
-        </p:nvSpPr>
-        <p:spPr>
-          <a:xfrm>
-            <a:off x="1737360" y="3712464"/>
-            <a:ext cx="5486400" cy="338328"/>
-          </a:xfrm>
-          <a:prstGeom prst="rect">
-            <a:avLst/>
-          </a:prstGeom>
-          <a:noFill/>
-        </p:spPr>
-        <p:txBody>
-          <a:bodyPr wrap="square" lIns="0" tIns="0" rIns="0" bIns="0" anchor="ctr">
-            <a:spAutoFit/>
-          </a:bodyPr>
-          <a:lstStyle/>
-          <a:p>
-            <a:pPr algn="l"/>
-            <a:r>
-              <a:rPr sz="1250" b="1">
-                <a:solidFill>
-                  <a:srgbClr val="2D1155"/>
-                </a:solidFill>
-                <a:latin typeface="Arial Black"/>
-              </a:rPr>
-              <a:t>Section 3 · Agentic Engineering</a:t>
-            </a:r>
-          </a:p>
-        </p:txBody>
-      </p:sp>
-      <p:sp>
-        <p:nvSpPr>
-          <p:cNvPr id="32" name="TextBox 31"/>
-          <p:cNvSpPr txBox="1"/>
-          <p:nvPr/>
-        </p:nvSpPr>
-        <p:spPr>
-          <a:xfrm>
-            <a:off x="566928" y="4050792"/>
-            <a:ext cx="1005840" cy="338328"/>
-          </a:xfrm>
-          <a:prstGeom prst="rect">
-            <a:avLst/>
-          </a:prstGeom>
-          <a:noFill/>
-        </p:spPr>
-        <p:txBody>
-          <a:bodyPr wrap="square" lIns="0" tIns="0" rIns="0" bIns="0" anchor="ctr">
-            <a:spAutoFit/>
-          </a:bodyPr>
-          <a:lstStyle/>
-          <a:p>
-            <a:pPr algn="l"/>
-            <a:r>
-              <a:rPr sz="1200" b="1">
-                <a:solidFill>
-                  <a:srgbClr val="7C3AED"/>
-                </a:solidFill>
-                <a:latin typeface="Calibri"/>
-              </a:rPr>
-              <a:t>15:45</a:t>
-            </a:r>
-          </a:p>
-        </p:txBody>
-      </p:sp>
-      <p:sp>
-        <p:nvSpPr>
-          <p:cNvPr id="33" name="TextBox 32"/>
-          <p:cNvSpPr txBox="1"/>
-          <p:nvPr/>
-        </p:nvSpPr>
-        <p:spPr>
-          <a:xfrm>
-            <a:off x="1737360" y="4050792"/>
-            <a:ext cx="5486400" cy="338328"/>
-          </a:xfrm>
-          <a:prstGeom prst="rect">
-            <a:avLst/>
-          </a:prstGeom>
-          <a:noFill/>
-        </p:spPr>
-        <p:txBody>
-          <a:bodyPr wrap="square" lIns="0" tIns="0" rIns="0" bIns="0" anchor="ctr">
-            <a:spAutoFit/>
-          </a:bodyPr>
-          <a:lstStyle/>
-          <a:p>
-            <a:pPr algn="l"/>
-            <a:r>
-              <a:rPr sz="1200" b="0">
-                <a:solidFill>
-                  <a:srgbClr val="6E6389"/>
-                </a:solidFill>
-                <a:latin typeface="Calibri"/>
-              </a:rPr>
-              <a:t>Showcase and close</a:t>
-            </a:r>
-          </a:p>
-        </p:txBody>
-      </p:sp>
-      <p:sp>
-        <p:nvSpPr>
-          <p:cNvPr id="35" name="TextBox 34"/>
-          <p:cNvSpPr txBox="1"/>
-          <p:nvPr/>
-        </p:nvSpPr>
-        <p:spPr>
-          <a:xfrm>
-            <a:off x="566928" y="4389120"/>
-            <a:ext cx="1005840" cy="338328"/>
-          </a:xfrm>
-          <a:prstGeom prst="rect">
-            <a:avLst/>
-          </a:prstGeom>
-          <a:noFill/>
-        </p:spPr>
-        <p:txBody>
-          <a:bodyPr wrap="square" lIns="0" tIns="0" rIns="0" bIns="0" anchor="ctr">
-            <a:spAutoFit/>
-          </a:bodyPr>
-          <a:lstStyle/>
-          <a:p>
-            <a:pPr algn="l"/>
-            <a:r>
-              <a:rPr sz="1200" b="1">
-                <a:solidFill>
-                  <a:srgbClr val="7C3AED"/>
-                </a:solidFill>
-                <a:latin typeface="Calibri"/>
-              </a:rPr>
-              <a:t>16:00</a:t>
-            </a:r>
-          </a:p>
-        </p:txBody>
-      </p:sp>
-      <p:sp>
-        <p:nvSpPr>
-          <p:cNvPr id="36" name="TextBox 35"/>
-          <p:cNvSpPr txBox="1"/>
-          <p:nvPr/>
-        </p:nvSpPr>
-        <p:spPr>
-          <a:xfrm>
-            <a:off x="1737360" y="4389120"/>
-            <a:ext cx="5486400" cy="338328"/>
-          </a:xfrm>
-          <a:prstGeom prst="rect">
-            <a:avLst/>
-          </a:prstGeom>
-          <a:noFill/>
-        </p:spPr>
-        <p:txBody>
-          <a:bodyPr wrap="square" lIns="0" tIns="0" rIns="0" bIns="0" anchor="ctr">
-            <a:spAutoFit/>
-          </a:bodyPr>
-          <a:lstStyle/>
-          <a:p>
-            <a:pPr algn="l"/>
-            <a:r>
-              <a:rPr sz="1200" b="0">
-                <a:solidFill>
-                  <a:srgbClr val="6E6389"/>
-                </a:solidFill>
-                <a:latin typeface="Calibri"/>
-              </a:rPr>
-              <a:t>End</a:t>
-            </a:r>
-          </a:p>
-        </p:txBody>
-      </p:sp>
-      <p:sp>
-        <p:nvSpPr>
-          <p:cNvPr id="37" name="TextBox 36"/>
-          <p:cNvSpPr txBox="1"/>
-          <p:nvPr/>
-        </p:nvSpPr>
-        <p:spPr>
-          <a:xfrm>
-            <a:off x="7315200" y="4389120"/>
-            <a:ext cx="822960" cy="338328"/>
-          </a:xfrm>
-          <a:prstGeom prst="rect">
-            <a:avLst/>
-          </a:prstGeom>
-          <a:noFill/>
-        </p:spPr>
-        <p:txBody>
-          <a:bodyPr wrap="square" lIns="0" tIns="0" rIns="0" bIns="0" anchor="ctr">
-            <a:spAutoFit/>
-          </a:bodyPr>
-          <a:lstStyle/>
-          <a:p>
-            <a:pPr algn="r"/>
-            <a:endParaRPr/>
-          </a:p>
-        </p:txBody>
-      </p:sp>
-    </p:spTree>
-  </p:cSld>
-  <p:clrMapOvr>
-    <a:masterClrMapping/>
-  </p:clrMapOvr>
-</p:sld>
-</file>
-
-<file path=ppt/slides/slide4.xml><?xml version="1.0" encoding="utf-8"?>
 <p:sld xmlns:a="http://schemas.openxmlformats.org/drawingml/2006/main" xmlns:r="http://schemas.openxmlformats.org/officeDocument/2006/relationships" xmlns:p="http://schemas.openxmlformats.org/presentationml/2006/main">
   <p:cSld>
     <p:bg>
@@ -9068,7 +8645,7 @@
           <p:nvPr/>
         </p:nvPicPr>
         <p:blipFill>
-          <a:blip r:embed="rId2"/>
+          <a:blip r:embed="rId3"/>
           <a:stretch>
             <a:fillRect/>
           </a:stretch>
@@ -9096,27 +8673,1171 @@
           <p:nvPr>
             <p:extLst>
               <p:ext uri="{D42A27DB-BD31-4B8C-83A1-F6EECF244321}">
-                <p14:modId xmlns:p14="http://schemas.microsoft.com/office/powerpoint/2010/main" val="2019455860"/>
+                <p14:modId xmlns:p14="http://schemas.microsoft.com/office/powerpoint/2010/main" val="1635626018"/>
               </p:ext>
             </p:extLst>
           </p:nvPr>
         </p:nvGraphicFramePr>
         <p:xfrm>
-          <a:off x="127000" y="827617"/>
+          <a:off x="96896" y="334669"/>
           <a:ext cx="8890000" cy="4064000"/>
         </p:xfrm>
         <a:graphic>
           <a:graphicData uri="http://schemas.openxmlformats.org/drawingml/2006/diagram">
-            <dgm:relIds xmlns:dgm="http://schemas.openxmlformats.org/drawingml/2006/diagram" xmlns:r="http://schemas.openxmlformats.org/officeDocument/2006/relationships" r:dm="rId3" r:lo="rId4" r:qs="rId5" r:cs="rId6"/>
+            <dgm:relIds xmlns:dgm="http://schemas.openxmlformats.org/drawingml/2006/diagram" xmlns:r="http://schemas.openxmlformats.org/officeDocument/2006/relationships" r:dm="rId4" r:lo="rId5" r:qs="rId6" r:cs="rId7"/>
           </a:graphicData>
         </a:graphic>
       </p:graphicFrame>
+      <p:sp>
+        <p:nvSpPr>
+          <p:cNvPr id="3" name="Rectangle 2">
+            <a:extLst>
+              <a:ext uri="{FF2B5EF4-FFF2-40B4-BE49-F238E27FC236}">
+                <a16:creationId xmlns:a16="http://schemas.microsoft.com/office/drawing/2014/main" id="{9D6615D6-2057-3C3A-122C-51C1BF0AE89C}"/>
+              </a:ext>
+            </a:extLst>
+          </p:cNvPr>
+          <p:cNvSpPr/>
+          <p:nvPr/>
+        </p:nvSpPr>
+        <p:spPr>
+          <a:xfrm>
+            <a:off x="342900" y="3912377"/>
+            <a:ext cx="8229600" cy="548048"/>
+          </a:xfrm>
+          <a:prstGeom prst="rect">
+            <a:avLst/>
+          </a:prstGeom>
+          <a:solidFill>
+            <a:srgbClr val="2D1155"/>
+          </a:solidFill>
+          <a:ln w="19050">
+            <a:solidFill>
+              <a:srgbClr val="F59E0B"/>
+            </a:solidFill>
+          </a:ln>
+          <a:effectLst/>
+        </p:spPr>
+        <p:style>
+          <a:lnRef idx="1">
+            <a:schemeClr val="accent1"/>
+          </a:lnRef>
+          <a:fillRef idx="3">
+            <a:schemeClr val="accent1"/>
+          </a:fillRef>
+          <a:effectRef idx="2">
+            <a:schemeClr val="accent1"/>
+          </a:effectRef>
+          <a:fontRef idx="minor">
+            <a:schemeClr val="lt1"/>
+          </a:fontRef>
+        </p:style>
+        <p:txBody>
+          <a:bodyPr rtlCol="0" anchor="ctr"/>
+          <a:lstStyle/>
+          <a:p>
+            <a:pPr algn="ctr"/>
+            <a:endParaRPr/>
+          </a:p>
+        </p:txBody>
+      </p:sp>
+      <p:sp>
+        <p:nvSpPr>
+          <p:cNvPr id="5" name="TextBox 4">
+            <a:extLst>
+              <a:ext uri="{FF2B5EF4-FFF2-40B4-BE49-F238E27FC236}">
+                <a16:creationId xmlns:a16="http://schemas.microsoft.com/office/drawing/2014/main" id="{58E69711-1C4C-5427-3AC9-20A8E4D80972}"/>
+              </a:ext>
+            </a:extLst>
+          </p:cNvPr>
+          <p:cNvSpPr txBox="1"/>
+          <p:nvPr/>
+        </p:nvSpPr>
+        <p:spPr>
+          <a:xfrm>
+            <a:off x="822960" y="4028225"/>
+            <a:ext cx="7498079" cy="310085"/>
+          </a:xfrm>
+          <a:prstGeom prst="rect">
+            <a:avLst/>
+          </a:prstGeom>
+          <a:noFill/>
+        </p:spPr>
+        <p:txBody>
+          <a:bodyPr wrap="square" lIns="0" tIns="0" rIns="0" bIns="0" anchor="ctr">
+            <a:spAutoFit/>
+          </a:bodyPr>
+          <a:lstStyle/>
+          <a:p>
+            <a:pPr algn="ctr">
+              <a:lnSpc>
+                <a:spcPct val="105000"/>
+              </a:lnSpc>
+            </a:pPr>
+            <a:r>
+              <a:rPr lang="en-AU" sz="2000" b="0" dirty="0">
+                <a:solidFill>
+                  <a:srgbClr val="FFFFFF"/>
+                </a:solidFill>
+                <a:latin typeface="Calibri"/>
+              </a:rPr>
+              <a:t>What is the </a:t>
+            </a:r>
+            <a:r>
+              <a:rPr sz="2000" b="1" dirty="0">
+                <a:solidFill>
+                  <a:srgbClr val="F59E0B"/>
+                </a:solidFill>
+                <a:latin typeface="Arial Black"/>
+              </a:rPr>
+              <a:t>one </a:t>
+            </a:r>
+            <a:r>
+              <a:rPr lang="en-AU" sz="2000" b="1" dirty="0">
+                <a:solidFill>
+                  <a:srgbClr val="F59E0B"/>
+                </a:solidFill>
+                <a:latin typeface="Arial Black"/>
+              </a:rPr>
+              <a:t>habit</a:t>
+            </a:r>
+            <a:r>
+              <a:rPr sz="2000" b="0" dirty="0">
+                <a:solidFill>
+                  <a:srgbClr val="FFFFFF"/>
+                </a:solidFill>
+                <a:latin typeface="Calibri"/>
+              </a:rPr>
+              <a:t> </a:t>
+            </a:r>
+            <a:r>
+              <a:rPr lang="en-AU" sz="2000" b="0" dirty="0">
+                <a:solidFill>
+                  <a:srgbClr val="FFFFFF"/>
+                </a:solidFill>
+                <a:latin typeface="Calibri"/>
+              </a:rPr>
+              <a:t>you </a:t>
+            </a:r>
+            <a:r>
+              <a:rPr lang="en-AU" sz="2000" dirty="0">
+                <a:solidFill>
+                  <a:srgbClr val="FFFFFF"/>
+                </a:solidFill>
+                <a:latin typeface="Calibri"/>
+              </a:rPr>
+              <a:t>would love to stick to?</a:t>
+            </a:r>
+            <a:endParaRPr sz="2000" b="0" dirty="0">
+              <a:solidFill>
+                <a:srgbClr val="FFFFFF"/>
+              </a:solidFill>
+              <a:latin typeface="Calibri"/>
+            </a:endParaRPr>
+          </a:p>
+        </p:txBody>
+      </p:sp>
     </p:spTree>
     <p:extLst>
       <p:ext uri="{BB962C8B-B14F-4D97-AF65-F5344CB8AC3E}">
         <p14:creationId xmlns:p14="http://schemas.microsoft.com/office/powerpoint/2010/main" val="397022273"/>
       </p:ext>
     </p:extLst>
+  </p:cSld>
+  <p:clrMapOvr>
+    <a:masterClrMapping/>
+  </p:clrMapOvr>
+</p:sld>
+</file>
+
+<file path=ppt/slides/slide4.xml><?xml version="1.0" encoding="utf-8"?>
+<p:sld xmlns:a="http://schemas.openxmlformats.org/drawingml/2006/main" xmlns:r="http://schemas.openxmlformats.org/officeDocument/2006/relationships" xmlns:p="http://schemas.openxmlformats.org/presentationml/2006/main">
+  <p:cSld>
+    <p:bg>
+      <p:bgPr>
+        <a:solidFill>
+          <a:srgbClr val="F5F3FF"/>
+        </a:solidFill>
+        <a:effectLst/>
+      </p:bgPr>
+    </p:bg>
+    <p:spTree>
+      <p:nvGrpSpPr>
+        <p:cNvPr id="1" name=""/>
+        <p:cNvGrpSpPr/>
+        <p:nvPr/>
+      </p:nvGrpSpPr>
+      <p:grpSpPr>
+        <a:xfrm>
+          <a:off x="0" y="0"/>
+          <a:ext cx="0" cy="0"/>
+          <a:chOff x="0" y="0"/>
+          <a:chExt cx="0" cy="0"/>
+        </a:xfrm>
+      </p:grpSpPr>
+      <p:sp>
+        <p:nvSpPr>
+          <p:cNvPr id="2" name="TextBox 1"/>
+          <p:cNvSpPr txBox="1"/>
+          <p:nvPr/>
+        </p:nvSpPr>
+        <p:spPr>
+          <a:xfrm>
+            <a:off x="457200" y="292608"/>
+            <a:ext cx="8229600" cy="566928"/>
+          </a:xfrm>
+          <a:prstGeom prst="rect">
+            <a:avLst/>
+          </a:prstGeom>
+          <a:noFill/>
+        </p:spPr>
+        <p:txBody>
+          <a:bodyPr wrap="square" lIns="0" tIns="0" rIns="0" bIns="0" anchor="t">
+            <a:spAutoFit/>
+          </a:bodyPr>
+          <a:lstStyle/>
+          <a:p>
+            <a:pPr algn="l"/>
+            <a:r>
+              <a:rPr sz="2200" b="1">
+                <a:solidFill>
+                  <a:srgbClr val="2D1155"/>
+                </a:solidFill>
+                <a:latin typeface="Arial Black"/>
+              </a:rPr>
+              <a:t>RUN OF DAY</a:t>
+            </a:r>
+          </a:p>
+        </p:txBody>
+      </p:sp>
+      <p:sp>
+        <p:nvSpPr>
+          <p:cNvPr id="3" name="TextBox 2"/>
+          <p:cNvSpPr txBox="1"/>
+          <p:nvPr/>
+        </p:nvSpPr>
+        <p:spPr>
+          <a:xfrm>
+            <a:off x="475488" y="896112"/>
+            <a:ext cx="8229600" cy="329184"/>
+          </a:xfrm>
+          <a:prstGeom prst="rect">
+            <a:avLst/>
+          </a:prstGeom>
+          <a:noFill/>
+        </p:spPr>
+        <p:txBody>
+          <a:bodyPr wrap="square" lIns="0" tIns="0" rIns="0" bIns="0" anchor="t">
+            <a:spAutoFit/>
+          </a:bodyPr>
+          <a:lstStyle/>
+          <a:p>
+            <a:pPr algn="l"/>
+            <a:r>
+              <a:rPr sz="1300" b="0" dirty="0">
+                <a:solidFill>
+                  <a:srgbClr val="6E6389"/>
+                </a:solidFill>
+                <a:latin typeface="Calibri"/>
+              </a:rPr>
+              <a:t>Segment lengths are what matter. Times assume a 09:30 start.</a:t>
+            </a:r>
+          </a:p>
+        </p:txBody>
+      </p:sp>
+      <p:pic>
+        <p:nvPicPr>
+          <p:cNvPr id="4" name="Picture 3" descr="image1.jpeg"/>
+          <p:cNvPicPr>
+            <a:picLocks noChangeAspect="1"/>
+          </p:cNvPicPr>
+          <p:nvPr/>
+        </p:nvPicPr>
+        <p:blipFill>
+          <a:blip r:embed="rId2"/>
+          <a:stretch>
+            <a:fillRect/>
+          </a:stretch>
+        </p:blipFill>
+        <p:spPr>
+          <a:xfrm>
+            <a:off x="8366760" y="4526280"/>
+            <a:ext cx="411480" cy="411480"/>
+          </a:xfrm>
+          <a:prstGeom prst="rect">
+            <a:avLst/>
+          </a:prstGeom>
+        </p:spPr>
+      </p:pic>
+      <p:sp>
+        <p:nvSpPr>
+          <p:cNvPr id="5" name="TextBox 4"/>
+          <p:cNvSpPr txBox="1"/>
+          <p:nvPr/>
+        </p:nvSpPr>
+        <p:spPr>
+          <a:xfrm>
+            <a:off x="566928" y="1371600"/>
+            <a:ext cx="914400" cy="274320"/>
+          </a:xfrm>
+          <a:prstGeom prst="rect">
+            <a:avLst/>
+          </a:prstGeom>
+          <a:noFill/>
+        </p:spPr>
+        <p:txBody>
+          <a:bodyPr wrap="square" lIns="0" tIns="0" rIns="0" bIns="0" anchor="t">
+            <a:spAutoFit/>
+          </a:bodyPr>
+          <a:lstStyle/>
+          <a:p>
+            <a:pPr algn="l"/>
+            <a:r>
+              <a:rPr sz="900" b="1">
+                <a:solidFill>
+                  <a:srgbClr val="6E6389"/>
+                </a:solidFill>
+                <a:latin typeface="Calibri"/>
+              </a:rPr>
+              <a:t>TIME</a:t>
+            </a:r>
+          </a:p>
+        </p:txBody>
+      </p:sp>
+      <p:sp>
+        <p:nvSpPr>
+          <p:cNvPr id="6" name="TextBox 5"/>
+          <p:cNvSpPr txBox="1"/>
+          <p:nvPr/>
+        </p:nvSpPr>
+        <p:spPr>
+          <a:xfrm>
+            <a:off x="1737360" y="1371600"/>
+            <a:ext cx="5486400" cy="274320"/>
+          </a:xfrm>
+          <a:prstGeom prst="rect">
+            <a:avLst/>
+          </a:prstGeom>
+          <a:noFill/>
+        </p:spPr>
+        <p:txBody>
+          <a:bodyPr wrap="square" lIns="0" tIns="0" rIns="0" bIns="0" anchor="t">
+            <a:spAutoFit/>
+          </a:bodyPr>
+          <a:lstStyle/>
+          <a:p>
+            <a:pPr algn="l"/>
+            <a:r>
+              <a:rPr sz="900" b="1">
+                <a:solidFill>
+                  <a:srgbClr val="6E6389"/>
+                </a:solidFill>
+                <a:latin typeface="Calibri"/>
+              </a:rPr>
+              <a:t>SEGMENT</a:t>
+            </a:r>
+          </a:p>
+        </p:txBody>
+      </p:sp>
+      <p:sp>
+        <p:nvSpPr>
+          <p:cNvPr id="8" name="TextBox 7"/>
+          <p:cNvSpPr txBox="1"/>
+          <p:nvPr/>
+        </p:nvSpPr>
+        <p:spPr>
+          <a:xfrm>
+            <a:off x="566928" y="1682496"/>
+            <a:ext cx="1005840" cy="338328"/>
+          </a:xfrm>
+          <a:prstGeom prst="rect">
+            <a:avLst/>
+          </a:prstGeom>
+          <a:noFill/>
+        </p:spPr>
+        <p:txBody>
+          <a:bodyPr wrap="square" lIns="0" tIns="0" rIns="0" bIns="0" anchor="ctr">
+            <a:spAutoFit/>
+          </a:bodyPr>
+          <a:lstStyle/>
+          <a:p>
+            <a:pPr algn="l"/>
+            <a:r>
+              <a:rPr sz="1200" b="1">
+                <a:solidFill>
+                  <a:srgbClr val="7C3AED"/>
+                </a:solidFill>
+                <a:latin typeface="Calibri"/>
+              </a:rPr>
+              <a:t>09:30</a:t>
+            </a:r>
+          </a:p>
+        </p:txBody>
+      </p:sp>
+      <p:sp>
+        <p:nvSpPr>
+          <p:cNvPr id="9" name="TextBox 8"/>
+          <p:cNvSpPr txBox="1"/>
+          <p:nvPr/>
+        </p:nvSpPr>
+        <p:spPr>
+          <a:xfrm>
+            <a:off x="1737360" y="1682496"/>
+            <a:ext cx="5486400" cy="338328"/>
+          </a:xfrm>
+          <a:prstGeom prst="rect">
+            <a:avLst/>
+          </a:prstGeom>
+          <a:noFill/>
+        </p:spPr>
+        <p:txBody>
+          <a:bodyPr wrap="square" lIns="0" tIns="0" rIns="0" bIns="0" anchor="ctr">
+            <a:spAutoFit/>
+          </a:bodyPr>
+          <a:lstStyle/>
+          <a:p>
+            <a:pPr algn="l"/>
+            <a:r>
+              <a:rPr sz="1200" b="0">
+                <a:solidFill>
+                  <a:srgbClr val="6E6389"/>
+                </a:solidFill>
+                <a:latin typeface="Calibri"/>
+              </a:rPr>
+              <a:t>Welcome, introduction, setup check — the day’s shape</a:t>
+            </a:r>
+          </a:p>
+        </p:txBody>
+      </p:sp>
+      <p:sp>
+        <p:nvSpPr>
+          <p:cNvPr id="11" name="TextBox 10"/>
+          <p:cNvSpPr txBox="1"/>
+          <p:nvPr/>
+        </p:nvSpPr>
+        <p:spPr>
+          <a:xfrm>
+            <a:off x="566928" y="2020824"/>
+            <a:ext cx="1005840" cy="338328"/>
+          </a:xfrm>
+          <a:prstGeom prst="rect">
+            <a:avLst/>
+          </a:prstGeom>
+          <a:noFill/>
+        </p:spPr>
+        <p:txBody>
+          <a:bodyPr wrap="square" lIns="0" tIns="0" rIns="0" bIns="0" anchor="ctr">
+            <a:spAutoFit/>
+          </a:bodyPr>
+          <a:lstStyle/>
+          <a:p>
+            <a:pPr algn="l"/>
+            <a:r>
+              <a:rPr sz="1200" b="1">
+                <a:solidFill>
+                  <a:srgbClr val="7C3AED"/>
+                </a:solidFill>
+                <a:latin typeface="Calibri"/>
+              </a:rPr>
+              <a:t>09:45</a:t>
+            </a:r>
+          </a:p>
+        </p:txBody>
+      </p:sp>
+      <p:sp>
+        <p:nvSpPr>
+          <p:cNvPr id="12" name="TextBox 11"/>
+          <p:cNvSpPr txBox="1"/>
+          <p:nvPr/>
+        </p:nvSpPr>
+        <p:spPr>
+          <a:xfrm>
+            <a:off x="1737360" y="2020824"/>
+            <a:ext cx="5486400" cy="338328"/>
+          </a:xfrm>
+          <a:prstGeom prst="rect">
+            <a:avLst/>
+          </a:prstGeom>
+          <a:noFill/>
+        </p:spPr>
+        <p:txBody>
+          <a:bodyPr wrap="square" lIns="0" tIns="0" rIns="0" bIns="0" anchor="ctr">
+            <a:spAutoFit/>
+          </a:bodyPr>
+          <a:lstStyle/>
+          <a:p>
+            <a:pPr algn="l"/>
+            <a:r>
+              <a:rPr sz="1200" b="0" dirty="0">
+                <a:solidFill>
+                  <a:srgbClr val="6E6389"/>
+                </a:solidFill>
+                <a:latin typeface="Calibri"/>
+              </a:rPr>
+              <a:t>How the engineer’s life has changed</a:t>
+            </a:r>
+          </a:p>
+        </p:txBody>
+      </p:sp>
+      <p:sp>
+        <p:nvSpPr>
+          <p:cNvPr id="14" name="Rectangle 13"/>
+          <p:cNvSpPr/>
+          <p:nvPr/>
+        </p:nvSpPr>
+        <p:spPr>
+          <a:xfrm>
+            <a:off x="457200" y="2359152"/>
+            <a:ext cx="7680960" cy="338328"/>
+          </a:xfrm>
+          <a:prstGeom prst="rect">
+            <a:avLst/>
+          </a:prstGeom>
+          <a:solidFill>
+            <a:srgbClr val="FFFFFF"/>
+          </a:solidFill>
+          <a:ln w="12700">
+            <a:solidFill>
+              <a:srgbClr val="DDD6FE"/>
+            </a:solidFill>
+          </a:ln>
+          <a:effectLst/>
+        </p:spPr>
+        <p:style>
+          <a:lnRef idx="1">
+            <a:schemeClr val="accent1"/>
+          </a:lnRef>
+          <a:fillRef idx="3">
+            <a:schemeClr val="accent1"/>
+          </a:fillRef>
+          <a:effectRef idx="2">
+            <a:schemeClr val="accent1"/>
+          </a:effectRef>
+          <a:fontRef idx="minor">
+            <a:schemeClr val="lt1"/>
+          </a:fontRef>
+        </p:style>
+        <p:txBody>
+          <a:bodyPr rtlCol="0" anchor="ctr"/>
+          <a:lstStyle/>
+          <a:p>
+            <a:pPr algn="ctr"/>
+            <a:endParaRPr/>
+          </a:p>
+        </p:txBody>
+      </p:sp>
+      <p:sp>
+        <p:nvSpPr>
+          <p:cNvPr id="15" name="TextBox 14"/>
+          <p:cNvSpPr txBox="1"/>
+          <p:nvPr/>
+        </p:nvSpPr>
+        <p:spPr>
+          <a:xfrm>
+            <a:off x="566928" y="2359152"/>
+            <a:ext cx="1005840" cy="338328"/>
+          </a:xfrm>
+          <a:prstGeom prst="rect">
+            <a:avLst/>
+          </a:prstGeom>
+          <a:noFill/>
+        </p:spPr>
+        <p:txBody>
+          <a:bodyPr wrap="square" lIns="0" tIns="0" rIns="0" bIns="0" anchor="ctr">
+            <a:spAutoFit/>
+          </a:bodyPr>
+          <a:lstStyle/>
+          <a:p>
+            <a:pPr algn="l"/>
+            <a:r>
+              <a:rPr sz="1200" b="1">
+                <a:solidFill>
+                  <a:srgbClr val="7C3AED"/>
+                </a:solidFill>
+                <a:latin typeface="Calibri"/>
+              </a:rPr>
+              <a:t>10:00</a:t>
+            </a:r>
+          </a:p>
+        </p:txBody>
+      </p:sp>
+      <p:sp>
+        <p:nvSpPr>
+          <p:cNvPr id="16" name="TextBox 15"/>
+          <p:cNvSpPr txBox="1"/>
+          <p:nvPr/>
+        </p:nvSpPr>
+        <p:spPr>
+          <a:xfrm>
+            <a:off x="1737360" y="2359152"/>
+            <a:ext cx="5486400" cy="338328"/>
+          </a:xfrm>
+          <a:prstGeom prst="rect">
+            <a:avLst/>
+          </a:prstGeom>
+          <a:noFill/>
+        </p:spPr>
+        <p:txBody>
+          <a:bodyPr wrap="square" lIns="0" tIns="0" rIns="0" bIns="0" anchor="ctr">
+            <a:spAutoFit/>
+          </a:bodyPr>
+          <a:lstStyle/>
+          <a:p>
+            <a:pPr algn="l"/>
+            <a:r>
+              <a:rPr sz="1250" b="1">
+                <a:solidFill>
+                  <a:srgbClr val="2D1155"/>
+                </a:solidFill>
+                <a:latin typeface="Arial Black"/>
+              </a:rPr>
+              <a:t>Section 1 · Vibe Coding</a:t>
+            </a:r>
+          </a:p>
+        </p:txBody>
+      </p:sp>
+      <p:sp>
+        <p:nvSpPr>
+          <p:cNvPr id="18" name="TextBox 17"/>
+          <p:cNvSpPr txBox="1"/>
+          <p:nvPr/>
+        </p:nvSpPr>
+        <p:spPr>
+          <a:xfrm>
+            <a:off x="566928" y="2697480"/>
+            <a:ext cx="1005840" cy="338328"/>
+          </a:xfrm>
+          <a:prstGeom prst="rect">
+            <a:avLst/>
+          </a:prstGeom>
+          <a:noFill/>
+        </p:spPr>
+        <p:txBody>
+          <a:bodyPr wrap="square" lIns="0" tIns="0" rIns="0" bIns="0" anchor="ctr">
+            <a:spAutoFit/>
+          </a:bodyPr>
+          <a:lstStyle/>
+          <a:p>
+            <a:pPr algn="l"/>
+            <a:r>
+              <a:rPr sz="1200" b="1">
+                <a:solidFill>
+                  <a:srgbClr val="7C3AED"/>
+                </a:solidFill>
+                <a:latin typeface="Calibri"/>
+              </a:rPr>
+              <a:t>11:30</a:t>
+            </a:r>
+          </a:p>
+        </p:txBody>
+      </p:sp>
+      <p:sp>
+        <p:nvSpPr>
+          <p:cNvPr id="19" name="TextBox 18"/>
+          <p:cNvSpPr txBox="1"/>
+          <p:nvPr/>
+        </p:nvSpPr>
+        <p:spPr>
+          <a:xfrm>
+            <a:off x="1737360" y="2697480"/>
+            <a:ext cx="5486400" cy="338328"/>
+          </a:xfrm>
+          <a:prstGeom prst="rect">
+            <a:avLst/>
+          </a:prstGeom>
+          <a:noFill/>
+        </p:spPr>
+        <p:txBody>
+          <a:bodyPr wrap="square" lIns="0" tIns="0" rIns="0" bIns="0" anchor="ctr">
+            <a:spAutoFit/>
+          </a:bodyPr>
+          <a:lstStyle/>
+          <a:p>
+            <a:pPr algn="l"/>
+            <a:r>
+              <a:rPr sz="1200" b="0">
+                <a:solidFill>
+                  <a:srgbClr val="6E6389"/>
+                </a:solidFill>
+                <a:latin typeface="Calibri"/>
+              </a:rPr>
+              <a:t>Break</a:t>
+            </a:r>
+          </a:p>
+        </p:txBody>
+      </p:sp>
+      <p:sp>
+        <p:nvSpPr>
+          <p:cNvPr id="21" name="Rectangle 20"/>
+          <p:cNvSpPr/>
+          <p:nvPr/>
+        </p:nvSpPr>
+        <p:spPr>
+          <a:xfrm>
+            <a:off x="457200" y="3035808"/>
+            <a:ext cx="7680960" cy="338328"/>
+          </a:xfrm>
+          <a:prstGeom prst="rect">
+            <a:avLst/>
+          </a:prstGeom>
+          <a:solidFill>
+            <a:srgbClr val="FFFFFF"/>
+          </a:solidFill>
+          <a:ln w="12700">
+            <a:solidFill>
+              <a:srgbClr val="DDD6FE"/>
+            </a:solidFill>
+          </a:ln>
+          <a:effectLst/>
+        </p:spPr>
+        <p:style>
+          <a:lnRef idx="1">
+            <a:schemeClr val="accent1"/>
+          </a:lnRef>
+          <a:fillRef idx="3">
+            <a:schemeClr val="accent1"/>
+          </a:fillRef>
+          <a:effectRef idx="2">
+            <a:schemeClr val="accent1"/>
+          </a:effectRef>
+          <a:fontRef idx="minor">
+            <a:schemeClr val="lt1"/>
+          </a:fontRef>
+        </p:style>
+        <p:txBody>
+          <a:bodyPr rtlCol="0" anchor="ctr"/>
+          <a:lstStyle/>
+          <a:p>
+            <a:pPr algn="ctr"/>
+            <a:endParaRPr/>
+          </a:p>
+        </p:txBody>
+      </p:sp>
+      <p:sp>
+        <p:nvSpPr>
+          <p:cNvPr id="22" name="TextBox 21"/>
+          <p:cNvSpPr txBox="1"/>
+          <p:nvPr/>
+        </p:nvSpPr>
+        <p:spPr>
+          <a:xfrm>
+            <a:off x="566928" y="3035808"/>
+            <a:ext cx="1005840" cy="338328"/>
+          </a:xfrm>
+          <a:prstGeom prst="rect">
+            <a:avLst/>
+          </a:prstGeom>
+          <a:noFill/>
+        </p:spPr>
+        <p:txBody>
+          <a:bodyPr wrap="square" lIns="0" tIns="0" rIns="0" bIns="0" anchor="ctr">
+            <a:spAutoFit/>
+          </a:bodyPr>
+          <a:lstStyle/>
+          <a:p>
+            <a:pPr algn="l"/>
+            <a:r>
+              <a:rPr sz="1200" b="1">
+                <a:solidFill>
+                  <a:srgbClr val="7C3AED"/>
+                </a:solidFill>
+                <a:latin typeface="Calibri"/>
+              </a:rPr>
+              <a:t>11:45</a:t>
+            </a:r>
+          </a:p>
+        </p:txBody>
+      </p:sp>
+      <p:sp>
+        <p:nvSpPr>
+          <p:cNvPr id="23" name="TextBox 22"/>
+          <p:cNvSpPr txBox="1"/>
+          <p:nvPr/>
+        </p:nvSpPr>
+        <p:spPr>
+          <a:xfrm>
+            <a:off x="1737360" y="3035808"/>
+            <a:ext cx="5486400" cy="338328"/>
+          </a:xfrm>
+          <a:prstGeom prst="rect">
+            <a:avLst/>
+          </a:prstGeom>
+          <a:noFill/>
+        </p:spPr>
+        <p:txBody>
+          <a:bodyPr wrap="square" lIns="0" tIns="0" rIns="0" bIns="0" anchor="ctr">
+            <a:spAutoFit/>
+          </a:bodyPr>
+          <a:lstStyle/>
+          <a:p>
+            <a:pPr algn="l"/>
+            <a:r>
+              <a:rPr sz="1250" b="1">
+                <a:solidFill>
+                  <a:srgbClr val="2D1155"/>
+                </a:solidFill>
+                <a:latin typeface="Arial Black"/>
+              </a:rPr>
+              <a:t>Section 2 · Vibe Engineering</a:t>
+            </a:r>
+          </a:p>
+        </p:txBody>
+      </p:sp>
+      <p:sp>
+        <p:nvSpPr>
+          <p:cNvPr id="25" name="TextBox 24"/>
+          <p:cNvSpPr txBox="1"/>
+          <p:nvPr/>
+        </p:nvSpPr>
+        <p:spPr>
+          <a:xfrm>
+            <a:off x="566928" y="3374136"/>
+            <a:ext cx="1005840" cy="338328"/>
+          </a:xfrm>
+          <a:prstGeom prst="rect">
+            <a:avLst/>
+          </a:prstGeom>
+          <a:noFill/>
+        </p:spPr>
+        <p:txBody>
+          <a:bodyPr wrap="square" lIns="0" tIns="0" rIns="0" bIns="0" anchor="ctr">
+            <a:spAutoFit/>
+          </a:bodyPr>
+          <a:lstStyle/>
+          <a:p>
+            <a:pPr algn="l"/>
+            <a:r>
+              <a:rPr sz="1200" b="1">
+                <a:solidFill>
+                  <a:srgbClr val="7C3AED"/>
+                </a:solidFill>
+                <a:latin typeface="Calibri"/>
+              </a:rPr>
+              <a:t>13:15</a:t>
+            </a:r>
+          </a:p>
+        </p:txBody>
+      </p:sp>
+      <p:sp>
+        <p:nvSpPr>
+          <p:cNvPr id="26" name="TextBox 25"/>
+          <p:cNvSpPr txBox="1"/>
+          <p:nvPr/>
+        </p:nvSpPr>
+        <p:spPr>
+          <a:xfrm>
+            <a:off x="1737360" y="3374136"/>
+            <a:ext cx="5486400" cy="338328"/>
+          </a:xfrm>
+          <a:prstGeom prst="rect">
+            <a:avLst/>
+          </a:prstGeom>
+          <a:noFill/>
+        </p:spPr>
+        <p:txBody>
+          <a:bodyPr wrap="square" lIns="0" tIns="0" rIns="0" bIns="0" anchor="ctr">
+            <a:spAutoFit/>
+          </a:bodyPr>
+          <a:lstStyle/>
+          <a:p>
+            <a:pPr algn="l"/>
+            <a:r>
+              <a:rPr sz="1200" b="0">
+                <a:solidFill>
+                  <a:srgbClr val="6E6389"/>
+                </a:solidFill>
+                <a:latin typeface="Calibri"/>
+              </a:rPr>
+              <a:t>Lunch</a:t>
+            </a:r>
+          </a:p>
+        </p:txBody>
+      </p:sp>
+      <p:sp>
+        <p:nvSpPr>
+          <p:cNvPr id="28" name="Rectangle 27"/>
+          <p:cNvSpPr/>
+          <p:nvPr/>
+        </p:nvSpPr>
+        <p:spPr>
+          <a:xfrm>
+            <a:off x="457200" y="3712464"/>
+            <a:ext cx="7680960" cy="338328"/>
+          </a:xfrm>
+          <a:prstGeom prst="rect">
+            <a:avLst/>
+          </a:prstGeom>
+          <a:solidFill>
+            <a:srgbClr val="FFFFFF"/>
+          </a:solidFill>
+          <a:ln w="12700">
+            <a:solidFill>
+              <a:srgbClr val="DDD6FE"/>
+            </a:solidFill>
+          </a:ln>
+          <a:effectLst/>
+        </p:spPr>
+        <p:style>
+          <a:lnRef idx="1">
+            <a:schemeClr val="accent1"/>
+          </a:lnRef>
+          <a:fillRef idx="3">
+            <a:schemeClr val="accent1"/>
+          </a:fillRef>
+          <a:effectRef idx="2">
+            <a:schemeClr val="accent1"/>
+          </a:effectRef>
+          <a:fontRef idx="minor">
+            <a:schemeClr val="lt1"/>
+          </a:fontRef>
+        </p:style>
+        <p:txBody>
+          <a:bodyPr rtlCol="0" anchor="ctr"/>
+          <a:lstStyle/>
+          <a:p>
+            <a:pPr algn="ctr"/>
+            <a:endParaRPr/>
+          </a:p>
+        </p:txBody>
+      </p:sp>
+      <p:sp>
+        <p:nvSpPr>
+          <p:cNvPr id="29" name="TextBox 28"/>
+          <p:cNvSpPr txBox="1"/>
+          <p:nvPr/>
+        </p:nvSpPr>
+        <p:spPr>
+          <a:xfrm>
+            <a:off x="566928" y="3712464"/>
+            <a:ext cx="1005840" cy="338328"/>
+          </a:xfrm>
+          <a:prstGeom prst="rect">
+            <a:avLst/>
+          </a:prstGeom>
+          <a:noFill/>
+        </p:spPr>
+        <p:txBody>
+          <a:bodyPr wrap="square" lIns="0" tIns="0" rIns="0" bIns="0" anchor="ctr">
+            <a:spAutoFit/>
+          </a:bodyPr>
+          <a:lstStyle/>
+          <a:p>
+            <a:pPr algn="l"/>
+            <a:r>
+              <a:rPr sz="1200" b="1">
+                <a:solidFill>
+                  <a:srgbClr val="7C3AED"/>
+                </a:solidFill>
+                <a:latin typeface="Calibri"/>
+              </a:rPr>
+              <a:t>14:00</a:t>
+            </a:r>
+          </a:p>
+        </p:txBody>
+      </p:sp>
+      <p:sp>
+        <p:nvSpPr>
+          <p:cNvPr id="30" name="TextBox 29"/>
+          <p:cNvSpPr txBox="1"/>
+          <p:nvPr/>
+        </p:nvSpPr>
+        <p:spPr>
+          <a:xfrm>
+            <a:off x="1737360" y="3712464"/>
+            <a:ext cx="5486400" cy="338328"/>
+          </a:xfrm>
+          <a:prstGeom prst="rect">
+            <a:avLst/>
+          </a:prstGeom>
+          <a:noFill/>
+        </p:spPr>
+        <p:txBody>
+          <a:bodyPr wrap="square" lIns="0" tIns="0" rIns="0" bIns="0" anchor="ctr">
+            <a:spAutoFit/>
+          </a:bodyPr>
+          <a:lstStyle/>
+          <a:p>
+            <a:pPr algn="l"/>
+            <a:r>
+              <a:rPr sz="1250" b="1">
+                <a:solidFill>
+                  <a:srgbClr val="2D1155"/>
+                </a:solidFill>
+                <a:latin typeface="Arial Black"/>
+              </a:rPr>
+              <a:t>Section 3 · Agentic Engineering</a:t>
+            </a:r>
+          </a:p>
+        </p:txBody>
+      </p:sp>
+      <p:sp>
+        <p:nvSpPr>
+          <p:cNvPr id="32" name="TextBox 31"/>
+          <p:cNvSpPr txBox="1"/>
+          <p:nvPr/>
+        </p:nvSpPr>
+        <p:spPr>
+          <a:xfrm>
+            <a:off x="566928" y="4050792"/>
+            <a:ext cx="1005840" cy="338328"/>
+          </a:xfrm>
+          <a:prstGeom prst="rect">
+            <a:avLst/>
+          </a:prstGeom>
+          <a:noFill/>
+        </p:spPr>
+        <p:txBody>
+          <a:bodyPr wrap="square" lIns="0" tIns="0" rIns="0" bIns="0" anchor="ctr">
+            <a:spAutoFit/>
+          </a:bodyPr>
+          <a:lstStyle/>
+          <a:p>
+            <a:pPr algn="l"/>
+            <a:r>
+              <a:rPr sz="1200" b="1">
+                <a:solidFill>
+                  <a:srgbClr val="7C3AED"/>
+                </a:solidFill>
+                <a:latin typeface="Calibri"/>
+              </a:rPr>
+              <a:t>15:45</a:t>
+            </a:r>
+          </a:p>
+        </p:txBody>
+      </p:sp>
+      <p:sp>
+        <p:nvSpPr>
+          <p:cNvPr id="33" name="TextBox 32"/>
+          <p:cNvSpPr txBox="1"/>
+          <p:nvPr/>
+        </p:nvSpPr>
+        <p:spPr>
+          <a:xfrm>
+            <a:off x="1737360" y="4050792"/>
+            <a:ext cx="5486400" cy="338328"/>
+          </a:xfrm>
+          <a:prstGeom prst="rect">
+            <a:avLst/>
+          </a:prstGeom>
+          <a:noFill/>
+        </p:spPr>
+        <p:txBody>
+          <a:bodyPr wrap="square" lIns="0" tIns="0" rIns="0" bIns="0" anchor="ctr">
+            <a:spAutoFit/>
+          </a:bodyPr>
+          <a:lstStyle/>
+          <a:p>
+            <a:pPr algn="l"/>
+            <a:r>
+              <a:rPr sz="1200" b="0">
+                <a:solidFill>
+                  <a:srgbClr val="6E6389"/>
+                </a:solidFill>
+                <a:latin typeface="Calibri"/>
+              </a:rPr>
+              <a:t>Showcase and close</a:t>
+            </a:r>
+          </a:p>
+        </p:txBody>
+      </p:sp>
+      <p:sp>
+        <p:nvSpPr>
+          <p:cNvPr id="35" name="TextBox 34"/>
+          <p:cNvSpPr txBox="1"/>
+          <p:nvPr/>
+        </p:nvSpPr>
+        <p:spPr>
+          <a:xfrm>
+            <a:off x="566928" y="4389120"/>
+            <a:ext cx="1005840" cy="338328"/>
+          </a:xfrm>
+          <a:prstGeom prst="rect">
+            <a:avLst/>
+          </a:prstGeom>
+          <a:noFill/>
+        </p:spPr>
+        <p:txBody>
+          <a:bodyPr wrap="square" lIns="0" tIns="0" rIns="0" bIns="0" anchor="ctr">
+            <a:spAutoFit/>
+          </a:bodyPr>
+          <a:lstStyle/>
+          <a:p>
+            <a:pPr algn="l"/>
+            <a:r>
+              <a:rPr sz="1200" b="1">
+                <a:solidFill>
+                  <a:srgbClr val="7C3AED"/>
+                </a:solidFill>
+                <a:latin typeface="Calibri"/>
+              </a:rPr>
+              <a:t>16:00</a:t>
+            </a:r>
+          </a:p>
+        </p:txBody>
+      </p:sp>
+      <p:sp>
+        <p:nvSpPr>
+          <p:cNvPr id="36" name="TextBox 35"/>
+          <p:cNvSpPr txBox="1"/>
+          <p:nvPr/>
+        </p:nvSpPr>
+        <p:spPr>
+          <a:xfrm>
+            <a:off x="1737360" y="4389120"/>
+            <a:ext cx="5486400" cy="338328"/>
+          </a:xfrm>
+          <a:prstGeom prst="rect">
+            <a:avLst/>
+          </a:prstGeom>
+          <a:noFill/>
+        </p:spPr>
+        <p:txBody>
+          <a:bodyPr wrap="square" lIns="0" tIns="0" rIns="0" bIns="0" anchor="ctr">
+            <a:spAutoFit/>
+          </a:bodyPr>
+          <a:lstStyle/>
+          <a:p>
+            <a:pPr algn="l"/>
+            <a:r>
+              <a:rPr sz="1200" b="0">
+                <a:solidFill>
+                  <a:srgbClr val="6E6389"/>
+                </a:solidFill>
+                <a:latin typeface="Calibri"/>
+              </a:rPr>
+              <a:t>End</a:t>
+            </a:r>
+          </a:p>
+        </p:txBody>
+      </p:sp>
+      <p:sp>
+        <p:nvSpPr>
+          <p:cNvPr id="37" name="TextBox 36"/>
+          <p:cNvSpPr txBox="1"/>
+          <p:nvPr/>
+        </p:nvSpPr>
+        <p:spPr>
+          <a:xfrm>
+            <a:off x="7315200" y="4389120"/>
+            <a:ext cx="822960" cy="338328"/>
+          </a:xfrm>
+          <a:prstGeom prst="rect">
+            <a:avLst/>
+          </a:prstGeom>
+          <a:noFill/>
+        </p:spPr>
+        <p:txBody>
+          <a:bodyPr wrap="square" lIns="0" tIns="0" rIns="0" bIns="0" anchor="ctr">
+            <a:spAutoFit/>
+          </a:bodyPr>
+          <a:lstStyle/>
+          <a:p>
+            <a:pPr algn="r"/>
+            <a:endParaRPr/>
+          </a:p>
+        </p:txBody>
+      </p:sp>
+    </p:spTree>
   </p:cSld>
   <p:clrMapOvr>
     <a:masterClrMapping/>
@@ -9380,7 +10101,7 @@
           <a:p>
             <a:pPr algn="l"/>
             <a:r>
-              <a:rPr sz="1350" b="0">
+              <a:rPr sz="1350" b="0" dirty="0">
                 <a:solidFill>
                   <a:srgbClr val="6E6389"/>
                 </a:solidFill>
@@ -10328,7 +11049,7 @@
           <p:nvPr/>
         </p:nvPicPr>
         <p:blipFill>
-          <a:blip r:embed="rId2"/>
+          <a:blip r:embed="rId3"/>
           <a:stretch>
             <a:fillRect/>
           </a:stretch>
@@ -12134,4 +12855,319 @@
   </a:objectDefaults>
   <a:extraClrSchemeLst/>
 </a:theme>
+</file>
+
+<file path=ppt/theme/theme2.xml><?xml version="1.0" encoding="utf-8"?>
+<a:theme xmlns:a="http://schemas.openxmlformats.org/drawingml/2006/main" name="Office Theme">
+  <a:themeElements>
+    <a:clrScheme name="Office">
+      <a:dk1>
+        <a:sysClr val="windowText" lastClr="000000"/>
+      </a:dk1>
+      <a:lt1>
+        <a:sysClr val="window" lastClr="FFFFFF"/>
+      </a:lt1>
+      <a:dk2>
+        <a:srgbClr val="0E2841"/>
+      </a:dk2>
+      <a:lt2>
+        <a:srgbClr val="E8E8E8"/>
+      </a:lt2>
+      <a:accent1>
+        <a:srgbClr val="156082"/>
+      </a:accent1>
+      <a:accent2>
+        <a:srgbClr val="E97132"/>
+      </a:accent2>
+      <a:accent3>
+        <a:srgbClr val="196B24"/>
+      </a:accent3>
+      <a:accent4>
+        <a:srgbClr val="0F9ED5"/>
+      </a:accent4>
+      <a:accent5>
+        <a:srgbClr val="A02B93"/>
+      </a:accent5>
+      <a:accent6>
+        <a:srgbClr val="4EA72E"/>
+      </a:accent6>
+      <a:hlink>
+        <a:srgbClr val="467886"/>
+      </a:hlink>
+      <a:folHlink>
+        <a:srgbClr val="96607D"/>
+      </a:folHlink>
+    </a:clrScheme>
+    <a:fontScheme name="Office">
+      <a:majorFont>
+        <a:latin typeface="Aptos Display" panose="02110004020202020204"/>
+        <a:ea typeface=""/>
+        <a:cs typeface=""/>
+        <a:font script="Jpan" typeface="游ゴシック Light"/>
+        <a:font script="Hang" typeface="맑은 고딕"/>
+        <a:font script="Hans" typeface="等线 Light"/>
+        <a:font script="Hant" typeface="新細明體"/>
+        <a:font script="Arab" typeface="Times New Roman"/>
+        <a:font script="Hebr" typeface="Times New Roman"/>
+        <a:font script="Thai" typeface="Angsana New"/>
+        <a:font script="Ethi" typeface="Nyala"/>
+        <a:font script="Beng" typeface="Vrinda"/>
+        <a:font script="Gujr" typeface="Shruti"/>
+        <a:font script="Khmr" typeface="MoolBoran"/>
+        <a:font script="Knda" typeface="Tunga"/>
+        <a:font script="Guru" typeface="Raavi"/>
+        <a:font script="Cans" typeface="Euphemia"/>
+        <a:font script="Cher" typeface="Plantagenet Cherokee"/>
+        <a:font script="Yiii" typeface="Microsoft Yi Baiti"/>
+        <a:font script="Tibt" typeface="Microsoft Himalaya"/>
+        <a:font script="Thaa" typeface="MV Boli"/>
+        <a:font script="Deva" typeface="Mangal"/>
+        <a:font script="Telu" typeface="Gautami"/>
+        <a:font script="Taml" typeface="Latha"/>
+        <a:font script="Syrc" typeface="Estrangelo Edessa"/>
+        <a:font script="Orya" typeface="Kalinga"/>
+        <a:font script="Mlym" typeface="Kartika"/>
+        <a:font script="Laoo" typeface="DokChampa"/>
+        <a:font script="Sinh" typeface="Iskoola Pota"/>
+        <a:font script="Mong" typeface="Mongolian Baiti"/>
+        <a:font script="Viet" typeface="Times New Roman"/>
+        <a:font script="Uigh" typeface="Microsoft Uighur"/>
+        <a:font script="Geor" typeface="Sylfaen"/>
+        <a:font script="Armn" typeface="Arial"/>
+        <a:font script="Bugi" typeface="Leelawadee UI"/>
+        <a:font script="Bopo" typeface="Microsoft JhengHei"/>
+        <a:font script="Java" typeface="Javanese Text"/>
+        <a:font script="Lisu" typeface="Segoe UI"/>
+        <a:font script="Mymr" typeface="Myanmar Text"/>
+        <a:font script="Nkoo" typeface="Ebrima"/>
+        <a:font script="Olck" typeface="Nirmala UI"/>
+        <a:font script="Osma" typeface="Ebrima"/>
+        <a:font script="Phag" typeface="Phagspa"/>
+        <a:font script="Syrn" typeface="Estrangelo Edessa"/>
+        <a:font script="Syrj" typeface="Estrangelo Edessa"/>
+        <a:font script="Syre" typeface="Estrangelo Edessa"/>
+        <a:font script="Sora" typeface="Nirmala UI"/>
+        <a:font script="Tale" typeface="Microsoft Tai Le"/>
+        <a:font script="Talu" typeface="Microsoft New Tai Lue"/>
+        <a:font script="Tfng" typeface="Ebrima"/>
+      </a:majorFont>
+      <a:minorFont>
+        <a:latin typeface="Aptos" panose="02110004020202020204"/>
+        <a:ea typeface=""/>
+        <a:cs typeface=""/>
+        <a:font script="Jpan" typeface="游ゴシック"/>
+        <a:font script="Hang" typeface="맑은 고딕"/>
+        <a:font script="Hans" typeface="等线"/>
+        <a:font script="Hant" typeface="新細明體"/>
+        <a:font script="Arab" typeface="Arial"/>
+        <a:font script="Hebr" typeface="Arial"/>
+        <a:font script="Thai" typeface="Cordia New"/>
+        <a:font script="Ethi" typeface="Nyala"/>
+        <a:font script="Beng" typeface="Vrinda"/>
+        <a:font script="Gujr" typeface="Shruti"/>
+        <a:font script="Khmr" typeface="DaunPenh"/>
+        <a:font script="Knda" typeface="Tunga"/>
+        <a:font script="Guru" typeface="Raavi"/>
+        <a:font script="Cans" typeface="Euphemia"/>
+        <a:font script="Cher" typeface="Plantagenet Cherokee"/>
+        <a:font script="Yiii" typeface="Microsoft Yi Baiti"/>
+        <a:font script="Tibt" typeface="Microsoft Himalaya"/>
+        <a:font script="Thaa" typeface="MV Boli"/>
+        <a:font script="Deva" typeface="Mangal"/>
+        <a:font script="Telu" typeface="Gautami"/>
+        <a:font script="Taml" typeface="Latha"/>
+        <a:font script="Syrc" typeface="Estrangelo Edessa"/>
+        <a:font script="Orya" typeface="Kalinga"/>
+        <a:font script="Mlym" typeface="Kartika"/>
+        <a:font script="Laoo" typeface="DokChampa"/>
+        <a:font script="Sinh" typeface="Iskoola Pota"/>
+        <a:font script="Mong" typeface="Mongolian Baiti"/>
+        <a:font script="Viet" typeface="Arial"/>
+        <a:font script="Uigh" typeface="Microsoft Uighur"/>
+        <a:font script="Geor" typeface="Sylfaen"/>
+        <a:font script="Armn" typeface="Arial"/>
+        <a:font script="Bugi" typeface="Leelawadee UI"/>
+        <a:font script="Bopo" typeface="Microsoft JhengHei"/>
+        <a:font script="Java" typeface="Javanese Text"/>
+        <a:font script="Lisu" typeface="Segoe UI"/>
+        <a:font script="Mymr" typeface="Myanmar Text"/>
+        <a:font script="Nkoo" typeface="Ebrima"/>
+        <a:font script="Olck" typeface="Nirmala UI"/>
+        <a:font script="Osma" typeface="Ebrima"/>
+        <a:font script="Phag" typeface="Phagspa"/>
+        <a:font script="Syrn" typeface="Estrangelo Edessa"/>
+        <a:font script="Syrj" typeface="Estrangelo Edessa"/>
+        <a:font script="Syre" typeface="Estrangelo Edessa"/>
+        <a:font script="Sora" typeface="Nirmala UI"/>
+        <a:font script="Tale" typeface="Microsoft Tai Le"/>
+        <a:font script="Talu" typeface="Microsoft New Tai Lue"/>
+        <a:font script="Tfng" typeface="Ebrima"/>
+      </a:minorFont>
+    </a:fontScheme>
+    <a:fmtScheme name="Office">
+      <a:fillStyleLst>
+        <a:solidFill>
+          <a:schemeClr val="phClr"/>
+        </a:solidFill>
+        <a:gradFill rotWithShape="1">
+          <a:gsLst>
+            <a:gs pos="0">
+              <a:schemeClr val="phClr">
+                <a:lumMod val="110000"/>
+                <a:satMod val="105000"/>
+                <a:tint val="67000"/>
+              </a:schemeClr>
+            </a:gs>
+            <a:gs pos="50000">
+              <a:schemeClr val="phClr">
+                <a:lumMod val="105000"/>
+                <a:satMod val="103000"/>
+                <a:tint val="73000"/>
+              </a:schemeClr>
+            </a:gs>
+            <a:gs pos="100000">
+              <a:schemeClr val="phClr">
+                <a:lumMod val="105000"/>
+                <a:satMod val="109000"/>
+                <a:tint val="81000"/>
+              </a:schemeClr>
+            </a:gs>
+          </a:gsLst>
+          <a:lin ang="5400000" scaled="0"/>
+        </a:gradFill>
+        <a:gradFill rotWithShape="1">
+          <a:gsLst>
+            <a:gs pos="0">
+              <a:schemeClr val="phClr">
+                <a:satMod val="103000"/>
+                <a:lumMod val="102000"/>
+                <a:tint val="94000"/>
+              </a:schemeClr>
+            </a:gs>
+            <a:gs pos="50000">
+              <a:schemeClr val="phClr">
+                <a:satMod val="110000"/>
+                <a:lumMod val="100000"/>
+                <a:shade val="100000"/>
+              </a:schemeClr>
+            </a:gs>
+            <a:gs pos="100000">
+              <a:schemeClr val="phClr">
+                <a:lumMod val="99000"/>
+                <a:satMod val="120000"/>
+                <a:shade val="78000"/>
+              </a:schemeClr>
+            </a:gs>
+          </a:gsLst>
+          <a:lin ang="5400000" scaled="0"/>
+        </a:gradFill>
+      </a:fillStyleLst>
+      <a:lnStyleLst>
+        <a:ln w="12700" cap="flat" cmpd="sng" algn="ctr">
+          <a:solidFill>
+            <a:schemeClr val="phClr"/>
+          </a:solidFill>
+          <a:prstDash val="solid"/>
+          <a:miter lim="800000"/>
+        </a:ln>
+        <a:ln w="19050" cap="flat" cmpd="sng" algn="ctr">
+          <a:solidFill>
+            <a:schemeClr val="phClr"/>
+          </a:solidFill>
+          <a:prstDash val="solid"/>
+          <a:miter lim="800000"/>
+        </a:ln>
+        <a:ln w="25400" cap="flat" cmpd="sng" algn="ctr">
+          <a:solidFill>
+            <a:schemeClr val="phClr"/>
+          </a:solidFill>
+          <a:prstDash val="solid"/>
+          <a:miter lim="800000"/>
+        </a:ln>
+      </a:lnStyleLst>
+      <a:effectStyleLst>
+        <a:effectStyle>
+          <a:effectLst/>
+        </a:effectStyle>
+        <a:effectStyle>
+          <a:effectLst/>
+        </a:effectStyle>
+        <a:effectStyle>
+          <a:effectLst>
+            <a:outerShdw blurRad="57150" dist="19050" dir="5400000" algn="ctr" rotWithShape="0">
+              <a:srgbClr val="000000">
+                <a:alpha val="63000"/>
+              </a:srgbClr>
+            </a:outerShdw>
+          </a:effectLst>
+        </a:effectStyle>
+      </a:effectStyleLst>
+      <a:bgFillStyleLst>
+        <a:solidFill>
+          <a:schemeClr val="phClr"/>
+        </a:solidFill>
+        <a:solidFill>
+          <a:schemeClr val="phClr">
+            <a:tint val="95000"/>
+            <a:satMod val="170000"/>
+          </a:schemeClr>
+        </a:solidFill>
+        <a:gradFill rotWithShape="1">
+          <a:gsLst>
+            <a:gs pos="0">
+              <a:schemeClr val="phClr">
+                <a:tint val="93000"/>
+                <a:satMod val="150000"/>
+                <a:shade val="98000"/>
+                <a:lumMod val="102000"/>
+              </a:schemeClr>
+            </a:gs>
+            <a:gs pos="50000">
+              <a:schemeClr val="phClr">
+                <a:tint val="98000"/>
+                <a:satMod val="130000"/>
+                <a:shade val="90000"/>
+                <a:lumMod val="103000"/>
+              </a:schemeClr>
+            </a:gs>
+            <a:gs pos="100000">
+              <a:schemeClr val="phClr">
+                <a:shade val="63000"/>
+                <a:satMod val="120000"/>
+              </a:schemeClr>
+            </a:gs>
+          </a:gsLst>
+          <a:lin ang="5400000" scaled="0"/>
+        </a:gradFill>
+      </a:bgFillStyleLst>
+    </a:fmtScheme>
+  </a:themeElements>
+  <a:objectDefaults>
+    <a:lnDef>
+      <a:spPr/>
+      <a:bodyPr/>
+      <a:lstStyle/>
+      <a:style>
+        <a:lnRef idx="2">
+          <a:schemeClr val="accent1"/>
+        </a:lnRef>
+        <a:fillRef idx="0">
+          <a:schemeClr val="accent1"/>
+        </a:fillRef>
+        <a:effectRef idx="1">
+          <a:schemeClr val="accent1"/>
+        </a:effectRef>
+        <a:fontRef idx="minor">
+          <a:schemeClr val="tx1"/>
+        </a:fontRef>
+      </a:style>
+    </a:lnDef>
+  </a:objectDefaults>
+  <a:extraClrSchemeLst/>
+  <a:extLst>
+    <a:ext uri="{05A4C25C-085E-4340-85A3-A5531E510DB2}">
+      <thm15:themeFamily xmlns:thm15="http://schemas.microsoft.com/office/thememl/2012/main" name="Office Theme" id="{2E142A2C-CD16-42D6-873A-C26D2A0506FA}" vid="{1BDDFF52-6CD6-40A5-AB3C-68EB2F1E4D0A}"/>
+    </a:ext>
+  </a:extLst>
+</a:theme>
 </file>
</xml_diff>